<commit_message>
docs: add website and user portal screenshots to presentation
</commit_message>
<xml_diff>
--- a/DotLife_Presentation.pptx
+++ b/DotLife_Presentation.pptx
@@ -5,7 +5,7 @@
     <p:sldMasterId id="2147483648" r:id="rId1"/>
   </p:sldMasterIdLst>
   <p:notesMasterIdLst>
-    <p:notesMasterId r:id="rId18"/>
+    <p:notesMasterId r:id="rId24"/>
   </p:notesMasterIdLst>
   <p:sldIdLst>
     <p:sldId id="256" r:id="rId4"/>
@@ -22,12 +22,22 @@
     <p:sldId id="267" r:id="rId15"/>
     <p:sldId id="268" r:id="rId16"/>
     <p:sldId id="269" r:id="rId17"/>
-    <p:sldId id="270" r:id="rId22"/>
-    <p:sldId id="271" r:id="rId23"/>
-    <p:sldId id="272" r:id="rId24"/>
-    <p:sldId id="273" r:id="rId25"/>
-    <p:sldId id="274" r:id="rId26"/>
-    <p:sldId id="275" r:id="rId27"/>
+    <p:sldId id="270" r:id="rId18"/>
+    <p:sldId id="271" r:id="rId19"/>
+    <p:sldId id="272" r:id="rId20"/>
+    <p:sldId id="273" r:id="rId21"/>
+    <p:sldId id="274" r:id="rId22"/>
+    <p:sldId id="275" r:id="rId23"/>
+    <p:sldId id="276" r:id="rId28"/>
+    <p:sldId id="277" r:id="rId29"/>
+    <p:sldId id="278" r:id="rId30"/>
+    <p:sldId id="279" r:id="rId31"/>
+    <p:sldId id="280" r:id="rId32"/>
+    <p:sldId id="281" r:id="rId33"/>
+    <p:sldId id="282" r:id="rId34"/>
+    <p:sldId id="283" r:id="rId35"/>
+    <p:sldId id="284" r:id="rId36"/>
+    <p:sldId id="285" r:id="rId37"/>
   </p:sldIdLst>
   <p:sldSz cx="12191695" cy="6858000" type="screen4x3"/>
   <p:notesSz cx="6858000" cy="9144000"/>
@@ -153,7 +163,7 @@
       </p:grpSpPr>
       <p:sp>
         <p:nvSpPr>
-          <p:cNvPr id="2" name="Header Placeholder 1"/>
+          <p:cNvPr id="1642072538" name="Header Placeholder 1"/>
           <p:cNvSpPr>
             <a:spLocks noGrp="1"/>
           </p:cNvSpPr>
@@ -187,7 +197,7 @@
       </p:sp>
       <p:sp>
         <p:nvSpPr>
-          <p:cNvPr id="3" name="Date Placeholder 2"/>
+          <p:cNvPr id="1646423928" name="Date Placeholder 2"/>
           <p:cNvSpPr>
             <a:spLocks noGrp="1"/>
           </p:cNvSpPr>
@@ -221,7 +231,7 @@
       </p:sp>
       <p:sp>
         <p:nvSpPr>
-          <p:cNvPr id="3" name="Date Placeholder 2"/>
+          <p:cNvPr id="1563897073" name="Date Placeholder 2"/>
           <p:cNvSpPr>
             <a:spLocks noGrp="1"/>
           </p:cNvSpPr>
@@ -255,7 +265,7 @@
       </p:sp>
       <p:sp>
         <p:nvSpPr>
-          <p:cNvPr id="5" name="Notes Placeholder 4"/>
+          <p:cNvPr id="2014052616" name="Notes Placeholder 4"/>
           <p:cNvSpPr>
             <a:spLocks noGrp="1"/>
           </p:cNvSpPr>
@@ -285,7 +295,7 @@
       </p:sp>
       <p:sp>
         <p:nvSpPr>
-          <p:cNvPr id="6" name="Footer Placeholder 5"/>
+          <p:cNvPr id="1502358648" name="Footer Placeholder 5"/>
           <p:cNvSpPr>
             <a:spLocks noGrp="1"/>
           </p:cNvSpPr>
@@ -319,7 +329,7 @@
       </p:sp>
       <p:sp>
         <p:nvSpPr>
-          <p:cNvPr id="7" name="Slide Number Placeholder 6"/>
+          <p:cNvPr id="32895922" name="Slide Number Placeholder 6"/>
           <p:cNvSpPr>
             <a:spLocks noGrp="1"/>
           </p:cNvSpPr>
@@ -468,7 +478,7 @@
       </p:grpSpPr>
       <p:sp>
         <p:nvSpPr>
-          <p:cNvPr id="2" name="Slide Image Placeholder 1"/>
+          <p:cNvPr id="1201745946" name="Slide Image Placeholder 1"/>
           <p:cNvSpPr>
             <a:spLocks noChangeAspect="1" noGrp="1" noRot="1"/>
           </p:cNvSpPr>
@@ -480,7 +490,7 @@
       </p:sp>
       <p:sp>
         <p:nvSpPr>
-          <p:cNvPr id="3" name="Notes Placeholder 2"/>
+          <p:cNvPr id="1180072328" name="Notes Placeholder 2"/>
           <p:cNvSpPr>
             <a:spLocks noGrp="1"/>
           </p:cNvSpPr>
@@ -502,7 +512,7 @@
       </p:sp>
       <p:sp>
         <p:nvSpPr>
-          <p:cNvPr id="4" name="Slide Number Placeholder 3"/>
+          <p:cNvPr id="1615550186" name="Slide Number Placeholder 3"/>
           <p:cNvSpPr>
             <a:spLocks noGrp="1"/>
           </p:cNvSpPr>
@@ -553,7 +563,7 @@
       </p:grpSpPr>
       <p:sp>
         <p:nvSpPr>
-          <p:cNvPr id="2" name="Slide Image Placeholder 1"/>
+          <p:cNvPr id="615474650" name="Slide Image Placeholder 1"/>
           <p:cNvSpPr>
             <a:spLocks noChangeAspect="1" noGrp="1" noRot="1"/>
           </p:cNvSpPr>
@@ -565,7 +575,7 @@
       </p:sp>
       <p:sp>
         <p:nvSpPr>
-          <p:cNvPr id="3" name="Notes Placeholder 2"/>
+          <p:cNvPr id="1637298842" name="Notes Placeholder 2"/>
           <p:cNvSpPr>
             <a:spLocks noGrp="1"/>
           </p:cNvSpPr>
@@ -587,7 +597,7 @@
       </p:sp>
       <p:sp>
         <p:nvSpPr>
-          <p:cNvPr id="4" name="Slide Number Placeholder 3"/>
+          <p:cNvPr id="324825591" name="Slide Number Placeholder 3"/>
           <p:cNvSpPr>
             <a:spLocks noGrp="1"/>
           </p:cNvSpPr>
@@ -638,7 +648,7 @@
       </p:grpSpPr>
       <p:sp>
         <p:nvSpPr>
-          <p:cNvPr id="2" name="Slide Image Placeholder 1"/>
+          <p:cNvPr id="98896962" name="Slide Image Placeholder 1"/>
           <p:cNvSpPr>
             <a:spLocks noChangeAspect="1" noGrp="1" noRot="1"/>
           </p:cNvSpPr>
@@ -650,7 +660,7 @@
       </p:sp>
       <p:sp>
         <p:nvSpPr>
-          <p:cNvPr id="3" name="Notes Placeholder 2"/>
+          <p:cNvPr id="40941899" name="Notes Placeholder 2"/>
           <p:cNvSpPr>
             <a:spLocks noGrp="1"/>
           </p:cNvSpPr>
@@ -672,7 +682,7 @@
       </p:sp>
       <p:sp>
         <p:nvSpPr>
-          <p:cNvPr id="4" name="Slide Number Placeholder 3"/>
+          <p:cNvPr id="783173531" name="Slide Number Placeholder 3"/>
           <p:cNvSpPr>
             <a:spLocks noGrp="1"/>
           </p:cNvSpPr>
@@ -723,7 +733,7 @@
       </p:grpSpPr>
       <p:sp>
         <p:nvSpPr>
-          <p:cNvPr id="2" name="Slide Image Placeholder 1"/>
+          <p:cNvPr id="688947192" name="Slide Image Placeholder 1"/>
           <p:cNvSpPr>
             <a:spLocks noChangeAspect="1" noGrp="1" noRot="1"/>
           </p:cNvSpPr>
@@ -735,7 +745,7 @@
       </p:sp>
       <p:sp>
         <p:nvSpPr>
-          <p:cNvPr id="3" name="Notes Placeholder 2"/>
+          <p:cNvPr id="2086617531" name="Notes Placeholder 2"/>
           <p:cNvSpPr>
             <a:spLocks noGrp="1"/>
           </p:cNvSpPr>
@@ -757,7 +767,7 @@
       </p:sp>
       <p:sp>
         <p:nvSpPr>
-          <p:cNvPr id="4" name="Slide Number Placeholder 3"/>
+          <p:cNvPr id="1401435635" name="Slide Number Placeholder 3"/>
           <p:cNvSpPr>
             <a:spLocks noGrp="1"/>
           </p:cNvSpPr>
@@ -808,7 +818,7 @@
       </p:grpSpPr>
       <p:sp>
         <p:nvSpPr>
-          <p:cNvPr id="2" name="Slide Image Placeholder 1"/>
+          <p:cNvPr id="2006428889" name="Slide Image Placeholder 1"/>
           <p:cNvSpPr>
             <a:spLocks noChangeAspect="1" noGrp="1" noRot="1"/>
           </p:cNvSpPr>
@@ -820,7 +830,7 @@
       </p:sp>
       <p:sp>
         <p:nvSpPr>
-          <p:cNvPr id="3" name="Notes Placeholder 2"/>
+          <p:cNvPr id="1407436239" name="Notes Placeholder 2"/>
           <p:cNvSpPr>
             <a:spLocks noGrp="1"/>
           </p:cNvSpPr>
@@ -842,7 +852,7 @@
       </p:sp>
       <p:sp>
         <p:nvSpPr>
-          <p:cNvPr id="4" name="Slide Number Placeholder 3"/>
+          <p:cNvPr id="225615525" name="Slide Number Placeholder 3"/>
           <p:cNvSpPr>
             <a:spLocks noGrp="1"/>
           </p:cNvSpPr>
@@ -893,6 +903,91 @@
       </p:grpSpPr>
       <p:sp>
         <p:nvSpPr>
+          <p:cNvPr id="1623123289" name="Slide Image Placeholder 1"/>
+          <p:cNvSpPr>
+            <a:spLocks noChangeAspect="1" noGrp="1" noRot="1"/>
+          </p:cNvSpPr>
+          <p:nvPr>
+            <p:ph type="sldImg"/>
+          </p:nvPr>
+        </p:nvSpPr>
+        <p:spPr bwMode="auto"/>
+      </p:sp>
+      <p:sp>
+        <p:nvSpPr>
+          <p:cNvPr id="1657588515" name="Notes Placeholder 2"/>
+          <p:cNvSpPr>
+            <a:spLocks noGrp="1"/>
+          </p:cNvSpPr>
+          <p:nvPr>
+            <p:ph type="body" idx="1"/>
+          </p:nvPr>
+        </p:nvSpPr>
+        <p:spPr bwMode="auto"/>
+        <p:txBody>
+          <a:bodyPr/>
+          <a:lstStyle/>
+          <a:p>
+            <a:pPr>
+              <a:defRPr/>
+            </a:pPr>
+            <a:endParaRPr/>
+          </a:p>
+        </p:txBody>
+      </p:sp>
+      <p:sp>
+        <p:nvSpPr>
+          <p:cNvPr id="3906855" name="Slide Number Placeholder 3"/>
+          <p:cNvSpPr>
+            <a:spLocks noGrp="1"/>
+          </p:cNvSpPr>
+          <p:nvPr>
+            <p:ph type="sldNum" sz="quarter" idx="10"/>
+          </p:nvPr>
+        </p:nvSpPr>
+        <p:spPr bwMode="auto"/>
+        <p:txBody>
+          <a:bodyPr/>
+          <a:lstStyle/>
+          <a:p>
+            <a:pPr>
+              <a:defRPr/>
+            </a:pPr>
+            <a:fld id="{0D5C4F2D-006B-6C43-1107-5C32D3966426}" type="slidenum">
+              <a:rPr/>
+              <a:t/>
+            </a:fld>
+            <a:endParaRPr/>
+          </a:p>
+        </p:txBody>
+      </p:sp>
+    </p:spTree>
+  </p:cSld>
+  <p:clrMapOvr>
+    <a:masterClrMapping/>
+  </p:clrMapOvr>
+</p:notes>
+</file>
+
+<file path=ppt/notesSlides/notesSlide15.xml><?xml version="1.0" encoding="utf-8"?>
+<p:notes xmlns:a="http://schemas.openxmlformats.org/drawingml/2006/main" xmlns:r="http://schemas.openxmlformats.org/officeDocument/2006/relationships" xmlns:p="http://schemas.openxmlformats.org/presentationml/2006/main" xmlns:m="http://schemas.openxmlformats.org/officeDocument/2006/math" xmlns:w="http://schemas.openxmlformats.org/wordprocessingml/2006/main">
+  <p:cSld name="">
+    <p:spTree>
+      <p:nvGrpSpPr>
+        <p:cNvPr id="1" name=""/>
+        <p:cNvGrpSpPr/>
+        <p:nvPr/>
+      </p:nvGrpSpPr>
+      <p:grpSpPr bwMode="auto">
+        <a:xfrm>
+          <a:off x="0" y="0"/>
+          <a:ext cx="0" cy="0"/>
+          <a:chOff x="0" y="0"/>
+          <a:chExt cx="0" cy="0"/>
+        </a:xfrm>
+      </p:grpSpPr>
+      <p:sp>
+        <p:nvSpPr>
           <p:cNvPr id="2" name="Slide Image Placeholder 1"/>
           <p:cNvSpPr>
             <a:spLocks noChangeAspect="1" noGrp="1" noRot="1"/>
@@ -943,7 +1038,347 @@
             <a:pPr>
               <a:defRPr/>
             </a:pPr>
-            <a:fld id="{0D5C4F2D-006B-6C43-1107-5C32D3966426}" type="slidenum">
+            <a:fld id="{94E3EEBC-17A8-3135-E490-541257D6C4C3}" type="slidenum">
+              <a:rPr/>
+              <a:t/>
+            </a:fld>
+            <a:endParaRPr/>
+          </a:p>
+        </p:txBody>
+      </p:sp>
+    </p:spTree>
+  </p:cSld>
+  <p:clrMapOvr>
+    <a:masterClrMapping/>
+  </p:clrMapOvr>
+</p:notes>
+</file>
+
+<file path=ppt/notesSlides/notesSlide16.xml><?xml version="1.0" encoding="utf-8"?>
+<p:notes xmlns:a="http://schemas.openxmlformats.org/drawingml/2006/main" xmlns:r="http://schemas.openxmlformats.org/officeDocument/2006/relationships" xmlns:p="http://schemas.openxmlformats.org/presentationml/2006/main" xmlns:m="http://schemas.openxmlformats.org/officeDocument/2006/math" xmlns:w="http://schemas.openxmlformats.org/wordprocessingml/2006/main">
+  <p:cSld name="">
+    <p:spTree>
+      <p:nvGrpSpPr>
+        <p:cNvPr id="1" name=""/>
+        <p:cNvGrpSpPr/>
+        <p:nvPr/>
+      </p:nvGrpSpPr>
+      <p:grpSpPr bwMode="auto">
+        <a:xfrm>
+          <a:off x="0" y="0"/>
+          <a:ext cx="0" cy="0"/>
+          <a:chOff x="0" y="0"/>
+          <a:chExt cx="0" cy="0"/>
+        </a:xfrm>
+      </p:grpSpPr>
+      <p:sp>
+        <p:nvSpPr>
+          <p:cNvPr id="2" name="Slide Image Placeholder 1"/>
+          <p:cNvSpPr>
+            <a:spLocks noChangeAspect="1" noGrp="1" noRot="1"/>
+          </p:cNvSpPr>
+          <p:nvPr>
+            <p:ph type="sldImg"/>
+          </p:nvPr>
+        </p:nvSpPr>
+        <p:spPr bwMode="auto"/>
+      </p:sp>
+      <p:sp>
+        <p:nvSpPr>
+          <p:cNvPr id="3" name="Notes Placeholder 2"/>
+          <p:cNvSpPr>
+            <a:spLocks noGrp="1"/>
+          </p:cNvSpPr>
+          <p:nvPr>
+            <p:ph type="body" idx="1"/>
+          </p:nvPr>
+        </p:nvSpPr>
+        <p:spPr bwMode="auto"/>
+        <p:txBody>
+          <a:bodyPr/>
+          <a:lstStyle/>
+          <a:p>
+            <a:pPr>
+              <a:defRPr/>
+            </a:pPr>
+            <a:endParaRPr/>
+          </a:p>
+        </p:txBody>
+      </p:sp>
+      <p:sp>
+        <p:nvSpPr>
+          <p:cNvPr id="4" name="Slide Number Placeholder 3"/>
+          <p:cNvSpPr>
+            <a:spLocks noGrp="1"/>
+          </p:cNvSpPr>
+          <p:nvPr>
+            <p:ph type="sldNum" sz="quarter" idx="10"/>
+          </p:nvPr>
+        </p:nvSpPr>
+        <p:spPr bwMode="auto"/>
+        <p:txBody>
+          <a:bodyPr/>
+          <a:lstStyle/>
+          <a:p>
+            <a:pPr>
+              <a:defRPr/>
+            </a:pPr>
+            <a:fld id="{D1D82CB4-9F95-CFA3-7FEC-621DC048B4D9}" type="slidenum">
+              <a:rPr/>
+              <a:t/>
+            </a:fld>
+            <a:endParaRPr/>
+          </a:p>
+        </p:txBody>
+      </p:sp>
+    </p:spTree>
+  </p:cSld>
+  <p:clrMapOvr>
+    <a:masterClrMapping/>
+  </p:clrMapOvr>
+</p:notes>
+</file>
+
+<file path=ppt/notesSlides/notesSlide17.xml><?xml version="1.0" encoding="utf-8"?>
+<p:notes xmlns:a="http://schemas.openxmlformats.org/drawingml/2006/main" xmlns:r="http://schemas.openxmlformats.org/officeDocument/2006/relationships" xmlns:p="http://schemas.openxmlformats.org/presentationml/2006/main" xmlns:m="http://schemas.openxmlformats.org/officeDocument/2006/math" xmlns:w="http://schemas.openxmlformats.org/wordprocessingml/2006/main">
+  <p:cSld name="">
+    <p:spTree>
+      <p:nvGrpSpPr>
+        <p:cNvPr id="1" name=""/>
+        <p:cNvGrpSpPr/>
+        <p:nvPr/>
+      </p:nvGrpSpPr>
+      <p:grpSpPr bwMode="auto">
+        <a:xfrm>
+          <a:off x="0" y="0"/>
+          <a:ext cx="0" cy="0"/>
+          <a:chOff x="0" y="0"/>
+          <a:chExt cx="0" cy="0"/>
+        </a:xfrm>
+      </p:grpSpPr>
+      <p:sp>
+        <p:nvSpPr>
+          <p:cNvPr id="2" name="Slide Image Placeholder 1"/>
+          <p:cNvSpPr>
+            <a:spLocks noChangeAspect="1" noGrp="1" noRot="1"/>
+          </p:cNvSpPr>
+          <p:nvPr>
+            <p:ph type="sldImg"/>
+          </p:nvPr>
+        </p:nvSpPr>
+        <p:spPr bwMode="auto"/>
+      </p:sp>
+      <p:sp>
+        <p:nvSpPr>
+          <p:cNvPr id="3" name="Notes Placeholder 2"/>
+          <p:cNvSpPr>
+            <a:spLocks noGrp="1"/>
+          </p:cNvSpPr>
+          <p:nvPr>
+            <p:ph type="body" idx="1"/>
+          </p:nvPr>
+        </p:nvSpPr>
+        <p:spPr bwMode="auto"/>
+        <p:txBody>
+          <a:bodyPr/>
+          <a:lstStyle/>
+          <a:p>
+            <a:pPr>
+              <a:defRPr/>
+            </a:pPr>
+            <a:endParaRPr/>
+          </a:p>
+        </p:txBody>
+      </p:sp>
+      <p:sp>
+        <p:nvSpPr>
+          <p:cNvPr id="4" name="Slide Number Placeholder 3"/>
+          <p:cNvSpPr>
+            <a:spLocks noGrp="1"/>
+          </p:cNvSpPr>
+          <p:nvPr>
+            <p:ph type="sldNum" sz="quarter" idx="10"/>
+          </p:nvPr>
+        </p:nvSpPr>
+        <p:spPr bwMode="auto"/>
+        <p:txBody>
+          <a:bodyPr/>
+          <a:lstStyle/>
+          <a:p>
+            <a:pPr>
+              <a:defRPr/>
+            </a:pPr>
+            <a:fld id="{4F411A84-E738-F687-EFEF-2F270A01306F}" type="slidenum">
+              <a:rPr/>
+              <a:t/>
+            </a:fld>
+            <a:endParaRPr/>
+          </a:p>
+        </p:txBody>
+      </p:sp>
+    </p:spTree>
+  </p:cSld>
+  <p:clrMapOvr>
+    <a:masterClrMapping/>
+  </p:clrMapOvr>
+</p:notes>
+</file>
+
+<file path=ppt/notesSlides/notesSlide18.xml><?xml version="1.0" encoding="utf-8"?>
+<p:notes xmlns:a="http://schemas.openxmlformats.org/drawingml/2006/main" xmlns:r="http://schemas.openxmlformats.org/officeDocument/2006/relationships" xmlns:p="http://schemas.openxmlformats.org/presentationml/2006/main" xmlns:m="http://schemas.openxmlformats.org/officeDocument/2006/math" xmlns:w="http://schemas.openxmlformats.org/wordprocessingml/2006/main">
+  <p:cSld name="">
+    <p:spTree>
+      <p:nvGrpSpPr>
+        <p:cNvPr id="1" name=""/>
+        <p:cNvGrpSpPr/>
+        <p:nvPr/>
+      </p:nvGrpSpPr>
+      <p:grpSpPr bwMode="auto">
+        <a:xfrm>
+          <a:off x="0" y="0"/>
+          <a:ext cx="0" cy="0"/>
+          <a:chOff x="0" y="0"/>
+          <a:chExt cx="0" cy="0"/>
+        </a:xfrm>
+      </p:grpSpPr>
+      <p:sp>
+        <p:nvSpPr>
+          <p:cNvPr id="2" name="Slide Image Placeholder 1"/>
+          <p:cNvSpPr>
+            <a:spLocks noChangeAspect="1" noGrp="1" noRot="1"/>
+          </p:cNvSpPr>
+          <p:nvPr>
+            <p:ph type="sldImg"/>
+          </p:nvPr>
+        </p:nvSpPr>
+        <p:spPr bwMode="auto"/>
+      </p:sp>
+      <p:sp>
+        <p:nvSpPr>
+          <p:cNvPr id="3" name="Notes Placeholder 2"/>
+          <p:cNvSpPr>
+            <a:spLocks noGrp="1"/>
+          </p:cNvSpPr>
+          <p:nvPr>
+            <p:ph type="body" idx="1"/>
+          </p:nvPr>
+        </p:nvSpPr>
+        <p:spPr bwMode="auto"/>
+        <p:txBody>
+          <a:bodyPr/>
+          <a:lstStyle/>
+          <a:p>
+            <a:pPr>
+              <a:defRPr/>
+            </a:pPr>
+            <a:endParaRPr/>
+          </a:p>
+        </p:txBody>
+      </p:sp>
+      <p:sp>
+        <p:nvSpPr>
+          <p:cNvPr id="4" name="Slide Number Placeholder 3"/>
+          <p:cNvSpPr>
+            <a:spLocks noGrp="1"/>
+          </p:cNvSpPr>
+          <p:nvPr>
+            <p:ph type="sldNum" sz="quarter" idx="10"/>
+          </p:nvPr>
+        </p:nvSpPr>
+        <p:spPr bwMode="auto"/>
+        <p:txBody>
+          <a:bodyPr/>
+          <a:lstStyle/>
+          <a:p>
+            <a:pPr>
+              <a:defRPr/>
+            </a:pPr>
+            <a:fld id="{6C746648-14B9-F8E6-0DB6-2267EE64A38D}" type="slidenum">
+              <a:rPr/>
+              <a:t/>
+            </a:fld>
+            <a:endParaRPr/>
+          </a:p>
+        </p:txBody>
+      </p:sp>
+    </p:spTree>
+  </p:cSld>
+  <p:clrMapOvr>
+    <a:masterClrMapping/>
+  </p:clrMapOvr>
+</p:notes>
+</file>
+
+<file path=ppt/notesSlides/notesSlide19.xml><?xml version="1.0" encoding="utf-8"?>
+<p:notes xmlns:a="http://schemas.openxmlformats.org/drawingml/2006/main" xmlns:r="http://schemas.openxmlformats.org/officeDocument/2006/relationships" xmlns:p="http://schemas.openxmlformats.org/presentationml/2006/main" xmlns:m="http://schemas.openxmlformats.org/officeDocument/2006/math" xmlns:w="http://schemas.openxmlformats.org/wordprocessingml/2006/main">
+  <p:cSld name="">
+    <p:spTree>
+      <p:nvGrpSpPr>
+        <p:cNvPr id="1" name=""/>
+        <p:cNvGrpSpPr/>
+        <p:nvPr/>
+      </p:nvGrpSpPr>
+      <p:grpSpPr bwMode="auto">
+        <a:xfrm>
+          <a:off x="0" y="0"/>
+          <a:ext cx="0" cy="0"/>
+          <a:chOff x="0" y="0"/>
+          <a:chExt cx="0" cy="0"/>
+        </a:xfrm>
+      </p:grpSpPr>
+      <p:sp>
+        <p:nvSpPr>
+          <p:cNvPr id="2" name="Slide Image Placeholder 1"/>
+          <p:cNvSpPr>
+            <a:spLocks noChangeAspect="1" noGrp="1" noRot="1"/>
+          </p:cNvSpPr>
+          <p:nvPr>
+            <p:ph type="sldImg"/>
+          </p:nvPr>
+        </p:nvSpPr>
+        <p:spPr bwMode="auto"/>
+      </p:sp>
+      <p:sp>
+        <p:nvSpPr>
+          <p:cNvPr id="3" name="Notes Placeholder 2"/>
+          <p:cNvSpPr>
+            <a:spLocks noGrp="1"/>
+          </p:cNvSpPr>
+          <p:nvPr>
+            <p:ph type="body" idx="1"/>
+          </p:nvPr>
+        </p:nvSpPr>
+        <p:spPr bwMode="auto"/>
+        <p:txBody>
+          <a:bodyPr/>
+          <a:lstStyle/>
+          <a:p>
+            <a:pPr>
+              <a:defRPr/>
+            </a:pPr>
+            <a:endParaRPr/>
+          </a:p>
+        </p:txBody>
+      </p:sp>
+      <p:sp>
+        <p:nvSpPr>
+          <p:cNvPr id="4" name="Slide Number Placeholder 3"/>
+          <p:cNvSpPr>
+            <a:spLocks noGrp="1"/>
+          </p:cNvSpPr>
+          <p:nvPr>
+            <p:ph type="sldNum" sz="quarter" idx="10"/>
+          </p:nvPr>
+        </p:nvSpPr>
+        <p:spPr bwMode="auto"/>
+        <p:txBody>
+          <a:bodyPr/>
+          <a:lstStyle/>
+          <a:p>
+            <a:pPr>
+              <a:defRPr/>
+            </a:pPr>
+            <a:fld id="{F352A4B0-50EB-F4DA-F06E-3FC8766E8002}" type="slidenum">
               <a:rPr/>
               <a:t/>
             </a:fld>
@@ -978,6 +1413,91 @@
       </p:grpSpPr>
       <p:sp>
         <p:nvSpPr>
+          <p:cNvPr id="2132526410" name="Slide Image Placeholder 1"/>
+          <p:cNvSpPr>
+            <a:spLocks noChangeAspect="1" noGrp="1" noRot="1"/>
+          </p:cNvSpPr>
+          <p:nvPr>
+            <p:ph type="sldImg"/>
+          </p:nvPr>
+        </p:nvSpPr>
+        <p:spPr bwMode="auto"/>
+      </p:sp>
+      <p:sp>
+        <p:nvSpPr>
+          <p:cNvPr id="994593206" name="Notes Placeholder 2"/>
+          <p:cNvSpPr>
+            <a:spLocks noGrp="1"/>
+          </p:cNvSpPr>
+          <p:nvPr>
+            <p:ph type="body" idx="1"/>
+          </p:nvPr>
+        </p:nvSpPr>
+        <p:spPr bwMode="auto"/>
+        <p:txBody>
+          <a:bodyPr/>
+          <a:lstStyle/>
+          <a:p>
+            <a:pPr>
+              <a:defRPr/>
+            </a:pPr>
+            <a:endParaRPr/>
+          </a:p>
+        </p:txBody>
+      </p:sp>
+      <p:sp>
+        <p:nvSpPr>
+          <p:cNvPr id="892000324" name="Slide Number Placeholder 3"/>
+          <p:cNvSpPr>
+            <a:spLocks noGrp="1"/>
+          </p:cNvSpPr>
+          <p:nvPr>
+            <p:ph type="sldNum" sz="quarter" idx="10"/>
+          </p:nvPr>
+        </p:nvSpPr>
+        <p:spPr bwMode="auto"/>
+        <p:txBody>
+          <a:bodyPr/>
+          <a:lstStyle/>
+          <a:p>
+            <a:pPr>
+              <a:defRPr/>
+            </a:pPr>
+            <a:fld id="{5DE014D6-FD41-F37D-6701-9FA474D730A1}" type="slidenum">
+              <a:rPr/>
+              <a:t/>
+            </a:fld>
+            <a:endParaRPr/>
+          </a:p>
+        </p:txBody>
+      </p:sp>
+    </p:spTree>
+  </p:cSld>
+  <p:clrMapOvr>
+    <a:masterClrMapping/>
+  </p:clrMapOvr>
+</p:notes>
+</file>
+
+<file path=ppt/notesSlides/notesSlide20.xml><?xml version="1.0" encoding="utf-8"?>
+<p:notes xmlns:a="http://schemas.openxmlformats.org/drawingml/2006/main" xmlns:r="http://schemas.openxmlformats.org/officeDocument/2006/relationships" xmlns:p="http://schemas.openxmlformats.org/presentationml/2006/main" xmlns:m="http://schemas.openxmlformats.org/officeDocument/2006/math" xmlns:w="http://schemas.openxmlformats.org/wordprocessingml/2006/main">
+  <p:cSld name="">
+    <p:spTree>
+      <p:nvGrpSpPr>
+        <p:cNvPr id="1" name=""/>
+        <p:cNvGrpSpPr/>
+        <p:nvPr/>
+      </p:nvGrpSpPr>
+      <p:grpSpPr bwMode="auto">
+        <a:xfrm>
+          <a:off x="0" y="0"/>
+          <a:ext cx="0" cy="0"/>
+          <a:chOff x="0" y="0"/>
+          <a:chExt cx="0" cy="0"/>
+        </a:xfrm>
+      </p:grpSpPr>
+      <p:sp>
+        <p:nvSpPr>
           <p:cNvPr id="2" name="Slide Image Placeholder 1"/>
           <p:cNvSpPr>
             <a:spLocks noChangeAspect="1" noGrp="1" noRot="1"/>
@@ -1028,7 +1548,7 @@
             <a:pPr>
               <a:defRPr/>
             </a:pPr>
-            <a:fld id="{5DE014D6-FD41-F37D-6701-9FA474D730A1}" type="slidenum">
+            <a:fld id="{EF26B921-D7D3-4FA5-7DA6-4E4C3FBEE0AE}" type="slidenum">
               <a:rPr/>
               <a:t/>
             </a:fld>
@@ -1063,7 +1583,7 @@
       </p:grpSpPr>
       <p:sp>
         <p:nvSpPr>
-          <p:cNvPr id="2" name="Slide Image Placeholder 1"/>
+          <p:cNvPr id="1546851961" name="Slide Image Placeholder 1"/>
           <p:cNvSpPr>
             <a:spLocks noChangeAspect="1" noGrp="1" noRot="1"/>
           </p:cNvSpPr>
@@ -1075,7 +1595,7 @@
       </p:sp>
       <p:sp>
         <p:nvSpPr>
-          <p:cNvPr id="3" name="Notes Placeholder 2"/>
+          <p:cNvPr id="1543420209" name="Notes Placeholder 2"/>
           <p:cNvSpPr>
             <a:spLocks noGrp="1"/>
           </p:cNvSpPr>
@@ -1097,7 +1617,7 @@
       </p:sp>
       <p:sp>
         <p:nvSpPr>
-          <p:cNvPr id="4" name="Slide Number Placeholder 3"/>
+          <p:cNvPr id="1523569293" name="Slide Number Placeholder 3"/>
           <p:cNvSpPr>
             <a:spLocks noGrp="1"/>
           </p:cNvSpPr>
@@ -1148,7 +1668,7 @@
       </p:grpSpPr>
       <p:sp>
         <p:nvSpPr>
-          <p:cNvPr id="2" name="Slide Image Placeholder 1"/>
+          <p:cNvPr id="47157631" name="Slide Image Placeholder 1"/>
           <p:cNvSpPr>
             <a:spLocks noChangeAspect="1" noGrp="1" noRot="1"/>
           </p:cNvSpPr>
@@ -1160,7 +1680,7 @@
       </p:sp>
       <p:sp>
         <p:nvSpPr>
-          <p:cNvPr id="3" name="Notes Placeholder 2"/>
+          <p:cNvPr id="297267843" name="Notes Placeholder 2"/>
           <p:cNvSpPr>
             <a:spLocks noGrp="1"/>
           </p:cNvSpPr>
@@ -1182,7 +1702,7 @@
       </p:sp>
       <p:sp>
         <p:nvSpPr>
-          <p:cNvPr id="4" name="Slide Number Placeholder 3"/>
+          <p:cNvPr id="1744819339" name="Slide Number Placeholder 3"/>
           <p:cNvSpPr>
             <a:spLocks noGrp="1"/>
           </p:cNvSpPr>
@@ -1233,7 +1753,7 @@
       </p:grpSpPr>
       <p:sp>
         <p:nvSpPr>
-          <p:cNvPr id="2" name="Slide Image Placeholder 1"/>
+          <p:cNvPr id="1553945993" name="Slide Image Placeholder 1"/>
           <p:cNvSpPr>
             <a:spLocks noChangeAspect="1" noGrp="1" noRot="1"/>
           </p:cNvSpPr>
@@ -1245,7 +1765,7 @@
       </p:sp>
       <p:sp>
         <p:nvSpPr>
-          <p:cNvPr id="3" name="Notes Placeholder 2"/>
+          <p:cNvPr id="1249732543" name="Notes Placeholder 2"/>
           <p:cNvSpPr>
             <a:spLocks noGrp="1"/>
           </p:cNvSpPr>
@@ -1267,7 +1787,7 @@
       </p:sp>
       <p:sp>
         <p:nvSpPr>
-          <p:cNvPr id="4" name="Slide Number Placeholder 3"/>
+          <p:cNvPr id="1875695337" name="Slide Number Placeholder 3"/>
           <p:cNvSpPr>
             <a:spLocks noGrp="1"/>
           </p:cNvSpPr>
@@ -1318,7 +1838,7 @@
       </p:grpSpPr>
       <p:sp>
         <p:nvSpPr>
-          <p:cNvPr id="2" name="Slide Image Placeholder 1"/>
+          <p:cNvPr id="1978069027" name="Slide Image Placeholder 1"/>
           <p:cNvSpPr>
             <a:spLocks noChangeAspect="1" noGrp="1" noRot="1"/>
           </p:cNvSpPr>
@@ -1330,7 +1850,7 @@
       </p:sp>
       <p:sp>
         <p:nvSpPr>
-          <p:cNvPr id="3" name="Notes Placeholder 2"/>
+          <p:cNvPr id="1307277" name="Notes Placeholder 2"/>
           <p:cNvSpPr>
             <a:spLocks noGrp="1"/>
           </p:cNvSpPr>
@@ -1352,7 +1872,7 @@
       </p:sp>
       <p:sp>
         <p:nvSpPr>
-          <p:cNvPr id="4" name="Slide Number Placeholder 3"/>
+          <p:cNvPr id="423485423" name="Slide Number Placeholder 3"/>
           <p:cNvSpPr>
             <a:spLocks noGrp="1"/>
           </p:cNvSpPr>
@@ -1403,7 +1923,7 @@
       </p:grpSpPr>
       <p:sp>
         <p:nvSpPr>
-          <p:cNvPr id="2" name="Slide Image Placeholder 1"/>
+          <p:cNvPr id="749422022" name="Slide Image Placeholder 1"/>
           <p:cNvSpPr>
             <a:spLocks noChangeAspect="1" noGrp="1" noRot="1"/>
           </p:cNvSpPr>
@@ -1415,7 +1935,7 @@
       </p:sp>
       <p:sp>
         <p:nvSpPr>
-          <p:cNvPr id="3" name="Notes Placeholder 2"/>
+          <p:cNvPr id="376694280" name="Notes Placeholder 2"/>
           <p:cNvSpPr>
             <a:spLocks noGrp="1"/>
           </p:cNvSpPr>
@@ -1437,7 +1957,7 @@
       </p:sp>
       <p:sp>
         <p:nvSpPr>
-          <p:cNvPr id="4" name="Slide Number Placeholder 3"/>
+          <p:cNvPr id="1024204210" name="Slide Number Placeholder 3"/>
           <p:cNvSpPr>
             <a:spLocks noGrp="1"/>
           </p:cNvSpPr>
@@ -1488,7 +2008,7 @@
       </p:grpSpPr>
       <p:sp>
         <p:nvSpPr>
-          <p:cNvPr id="2" name="Slide Image Placeholder 1"/>
+          <p:cNvPr id="1725961148" name="Slide Image Placeholder 1"/>
           <p:cNvSpPr>
             <a:spLocks noChangeAspect="1" noGrp="1" noRot="1"/>
           </p:cNvSpPr>
@@ -1500,7 +2020,7 @@
       </p:sp>
       <p:sp>
         <p:nvSpPr>
-          <p:cNvPr id="3" name="Notes Placeholder 2"/>
+          <p:cNvPr id="359271146" name="Notes Placeholder 2"/>
           <p:cNvSpPr>
             <a:spLocks noGrp="1"/>
           </p:cNvSpPr>
@@ -1522,7 +2042,7 @@
       </p:sp>
       <p:sp>
         <p:nvSpPr>
-          <p:cNvPr id="4" name="Slide Number Placeholder 3"/>
+          <p:cNvPr id="787830946" name="Slide Number Placeholder 3"/>
           <p:cNvSpPr>
             <a:spLocks noGrp="1"/>
           </p:cNvSpPr>
@@ -1573,7 +2093,7 @@
       </p:grpSpPr>
       <p:sp>
         <p:nvSpPr>
-          <p:cNvPr id="2" name="Slide Image Placeholder 1"/>
+          <p:cNvPr id="331483802" name="Slide Image Placeholder 1"/>
           <p:cNvSpPr>
             <a:spLocks noChangeAspect="1" noGrp="1" noRot="1"/>
           </p:cNvSpPr>
@@ -1585,7 +2105,7 @@
       </p:sp>
       <p:sp>
         <p:nvSpPr>
-          <p:cNvPr id="3" name="Notes Placeholder 2"/>
+          <p:cNvPr id="58489347" name="Notes Placeholder 2"/>
           <p:cNvSpPr>
             <a:spLocks noGrp="1"/>
           </p:cNvSpPr>
@@ -1607,7 +2127,7 @@
       </p:sp>
       <p:sp>
         <p:nvSpPr>
-          <p:cNvPr id="4" name="Slide Number Placeholder 3"/>
+          <p:cNvPr id="1283516215" name="Slide Number Placeholder 3"/>
           <p:cNvSpPr>
             <a:spLocks noGrp="1"/>
           </p:cNvSpPr>
@@ -1658,7 +2178,7 @@
       </p:grpSpPr>
       <p:sp>
         <p:nvSpPr>
-          <p:cNvPr id="538527070" name="Title 1"/>
+          <p:cNvPr id="997684981" name="Title 1"/>
           <p:cNvSpPr>
             <a:spLocks noGrp="1"/>
           </p:cNvSpPr>
@@ -1689,7 +2209,7 @@
       </p:sp>
       <p:sp>
         <p:nvSpPr>
-          <p:cNvPr id="1215992663" name="Subtitle 2"/>
+          <p:cNvPr id="349723942" name="Subtitle 2"/>
           <p:cNvSpPr>
             <a:spLocks noGrp="1"/>
           </p:cNvSpPr>
@@ -1811,7 +2331,7 @@
       </p:sp>
       <p:sp>
         <p:nvSpPr>
-          <p:cNvPr id="688602149" name="Date Placeholder 3"/>
+          <p:cNvPr id="868173201" name="Date Placeholder 3"/>
           <p:cNvSpPr>
             <a:spLocks noGrp="1"/>
           </p:cNvSpPr>
@@ -1837,7 +2357,7 @@
       </p:sp>
       <p:sp>
         <p:nvSpPr>
-          <p:cNvPr id="1990958554" name="Footer Placeholder 4"/>
+          <p:cNvPr id="865402541" name="Footer Placeholder 4"/>
           <p:cNvSpPr>
             <a:spLocks noGrp="1"/>
           </p:cNvSpPr>
@@ -1859,7 +2379,7 @@
       </p:sp>
       <p:sp>
         <p:nvSpPr>
-          <p:cNvPr id="631622959" name="Slide Number Placeholder 5"/>
+          <p:cNvPr id="1676838725" name="Slide Number Placeholder 5"/>
           <p:cNvSpPr>
             <a:spLocks noGrp="1"/>
           </p:cNvSpPr>
@@ -1910,7 +2430,7 @@
       </p:grpSpPr>
       <p:sp>
         <p:nvSpPr>
-          <p:cNvPr id="906886810" name="Title 1"/>
+          <p:cNvPr id="1491954503" name="Title 1"/>
           <p:cNvSpPr>
             <a:spLocks noGrp="1"/>
           </p:cNvSpPr>
@@ -1936,7 +2456,7 @@
       </p:sp>
       <p:sp>
         <p:nvSpPr>
-          <p:cNvPr id="853485635" name="Vertical Text Placeholder 2"/>
+          <p:cNvPr id="1877046629" name="Vertical Text Placeholder 2"/>
           <p:cNvSpPr>
             <a:spLocks noGrp="1"/>
           </p:cNvSpPr>
@@ -2002,7 +2522,7 @@
       </p:sp>
       <p:sp>
         <p:nvSpPr>
-          <p:cNvPr id="1865696801" name="Date Placeholder 3"/>
+          <p:cNvPr id="1054486683" name="Date Placeholder 3"/>
           <p:cNvSpPr>
             <a:spLocks noGrp="1"/>
           </p:cNvSpPr>
@@ -2028,7 +2548,7 @@
       </p:sp>
       <p:sp>
         <p:nvSpPr>
-          <p:cNvPr id="985455809" name="Footer Placeholder 4"/>
+          <p:cNvPr id="2105282737" name="Footer Placeholder 4"/>
           <p:cNvSpPr>
             <a:spLocks noGrp="1"/>
           </p:cNvSpPr>
@@ -2050,7 +2570,7 @@
       </p:sp>
       <p:sp>
         <p:nvSpPr>
-          <p:cNvPr id="1792960277" name="Slide Number Placeholder 5"/>
+          <p:cNvPr id="214730772" name="Slide Number Placeholder 5"/>
           <p:cNvSpPr>
             <a:spLocks noGrp="1"/>
           </p:cNvSpPr>
@@ -2101,7 +2621,7 @@
       </p:grpSpPr>
       <p:sp>
         <p:nvSpPr>
-          <p:cNvPr id="1319236612" name="Vertical Title 1"/>
+          <p:cNvPr id="662047952" name="Vertical Title 1"/>
           <p:cNvSpPr>
             <a:spLocks noGrp="1"/>
           </p:cNvSpPr>
@@ -2132,7 +2652,7 @@
       </p:sp>
       <p:sp>
         <p:nvSpPr>
-          <p:cNvPr id="1224763124" name="Vertical Text Placeholder 2"/>
+          <p:cNvPr id="542457140" name="Vertical Text Placeholder 2"/>
           <p:cNvSpPr>
             <a:spLocks noGrp="1"/>
           </p:cNvSpPr>
@@ -2203,7 +2723,7 @@
       </p:sp>
       <p:sp>
         <p:nvSpPr>
-          <p:cNvPr id="673276020" name="Date Placeholder 3"/>
+          <p:cNvPr id="59591958" name="Date Placeholder 3"/>
           <p:cNvSpPr>
             <a:spLocks noGrp="1"/>
           </p:cNvSpPr>
@@ -2229,7 +2749,7 @@
       </p:sp>
       <p:sp>
         <p:nvSpPr>
-          <p:cNvPr id="1806081858" name="Footer Placeholder 4"/>
+          <p:cNvPr id="1843068680" name="Footer Placeholder 4"/>
           <p:cNvSpPr>
             <a:spLocks noGrp="1"/>
           </p:cNvSpPr>
@@ -2251,7 +2771,7 @@
       </p:sp>
       <p:sp>
         <p:nvSpPr>
-          <p:cNvPr id="1349741651" name="Slide Number Placeholder 5"/>
+          <p:cNvPr id="2012846505" name="Slide Number Placeholder 5"/>
           <p:cNvSpPr>
             <a:spLocks noGrp="1"/>
           </p:cNvSpPr>
@@ -2302,7 +2822,7 @@
       </p:grpSpPr>
       <p:sp>
         <p:nvSpPr>
-          <p:cNvPr id="1573443576" name="Title 1"/>
+          <p:cNvPr id="1371328517" name="Title 1"/>
           <p:cNvSpPr>
             <a:spLocks noGrp="1"/>
           </p:cNvSpPr>
@@ -2328,7 +2848,7 @@
       </p:sp>
       <p:sp>
         <p:nvSpPr>
-          <p:cNvPr id="567226586" name="Content Placeholder 2"/>
+          <p:cNvPr id="1377872754" name="Content Placeholder 2"/>
           <p:cNvSpPr>
             <a:spLocks noGrp="1"/>
           </p:cNvSpPr>
@@ -2394,7 +2914,7 @@
       </p:sp>
       <p:sp>
         <p:nvSpPr>
-          <p:cNvPr id="1594118249" name="Date Placeholder 3"/>
+          <p:cNvPr id="1650330393" name="Date Placeholder 3"/>
           <p:cNvSpPr>
             <a:spLocks noGrp="1"/>
           </p:cNvSpPr>
@@ -2420,7 +2940,7 @@
       </p:sp>
       <p:sp>
         <p:nvSpPr>
-          <p:cNvPr id="496738885" name="Footer Placeholder 4"/>
+          <p:cNvPr id="1879998146" name="Footer Placeholder 4"/>
           <p:cNvSpPr>
             <a:spLocks noGrp="1"/>
           </p:cNvSpPr>
@@ -2442,7 +2962,7 @@
       </p:sp>
       <p:sp>
         <p:nvSpPr>
-          <p:cNvPr id="957073529" name="Slide Number Placeholder 5"/>
+          <p:cNvPr id="910697333" name="Slide Number Placeholder 5"/>
           <p:cNvSpPr>
             <a:spLocks noGrp="1"/>
           </p:cNvSpPr>
@@ -2493,7 +3013,7 @@
       </p:grpSpPr>
       <p:sp>
         <p:nvSpPr>
-          <p:cNvPr id="318288163" name="Title 1"/>
+          <p:cNvPr id="233149464" name="Title 1"/>
           <p:cNvSpPr>
             <a:spLocks noGrp="1"/>
           </p:cNvSpPr>
@@ -2528,7 +3048,7 @@
       </p:sp>
       <p:sp>
         <p:nvSpPr>
-          <p:cNvPr id="1267023656" name="Text Placeholder 2"/>
+          <p:cNvPr id="503815533" name="Text Placeholder 2"/>
           <p:cNvSpPr>
             <a:spLocks noGrp="1"/>
           </p:cNvSpPr>
@@ -2650,7 +3170,7 @@
       </p:sp>
       <p:sp>
         <p:nvSpPr>
-          <p:cNvPr id="1584509574" name="Date Placeholder 3"/>
+          <p:cNvPr id="1762420794" name="Date Placeholder 3"/>
           <p:cNvSpPr>
             <a:spLocks noGrp="1"/>
           </p:cNvSpPr>
@@ -2676,7 +3196,7 @@
       </p:sp>
       <p:sp>
         <p:nvSpPr>
-          <p:cNvPr id="527753742" name="Footer Placeholder 4"/>
+          <p:cNvPr id="183343068" name="Footer Placeholder 4"/>
           <p:cNvSpPr>
             <a:spLocks noGrp="1"/>
           </p:cNvSpPr>
@@ -2698,7 +3218,7 @@
       </p:sp>
       <p:sp>
         <p:nvSpPr>
-          <p:cNvPr id="169953781" name="Slide Number Placeholder 5"/>
+          <p:cNvPr id="1205430861" name="Slide Number Placeholder 5"/>
           <p:cNvSpPr>
             <a:spLocks noGrp="1"/>
           </p:cNvSpPr>
@@ -2749,7 +3269,7 @@
       </p:grpSpPr>
       <p:sp>
         <p:nvSpPr>
-          <p:cNvPr id="1940892388" name="Title 1"/>
+          <p:cNvPr id="824204539" name="Title 1"/>
           <p:cNvSpPr>
             <a:spLocks noGrp="1"/>
           </p:cNvSpPr>
@@ -2775,7 +3295,7 @@
       </p:sp>
       <p:sp>
         <p:nvSpPr>
-          <p:cNvPr id="1968690800" name="Content Placeholder 2"/>
+          <p:cNvPr id="697477388" name="Content Placeholder 2"/>
           <p:cNvSpPr>
             <a:spLocks noGrp="1"/>
           </p:cNvSpPr>
@@ -2874,7 +3394,7 @@
       </p:sp>
       <p:sp>
         <p:nvSpPr>
-          <p:cNvPr id="712127008" name="Content Placeholder 3"/>
+          <p:cNvPr id="39165774" name="Content Placeholder 3"/>
           <p:cNvSpPr>
             <a:spLocks noGrp="1"/>
           </p:cNvSpPr>
@@ -2973,7 +3493,7 @@
       </p:sp>
       <p:sp>
         <p:nvSpPr>
-          <p:cNvPr id="1353109184" name="Date Placeholder 4"/>
+          <p:cNvPr id="167158874" name="Date Placeholder 4"/>
           <p:cNvSpPr>
             <a:spLocks noGrp="1"/>
           </p:cNvSpPr>
@@ -2999,7 +3519,7 @@
       </p:sp>
       <p:sp>
         <p:nvSpPr>
-          <p:cNvPr id="1472829339" name="Footer Placeholder 5"/>
+          <p:cNvPr id="615065037" name="Footer Placeholder 5"/>
           <p:cNvSpPr>
             <a:spLocks noGrp="1"/>
           </p:cNvSpPr>
@@ -3021,7 +3541,7 @@
       </p:sp>
       <p:sp>
         <p:nvSpPr>
-          <p:cNvPr id="1574352690" name="Slide Number Placeholder 6"/>
+          <p:cNvPr id="634808371" name="Slide Number Placeholder 6"/>
           <p:cNvSpPr>
             <a:spLocks noGrp="1"/>
           </p:cNvSpPr>
@@ -3072,7 +3592,7 @@
       </p:grpSpPr>
       <p:sp>
         <p:nvSpPr>
-          <p:cNvPr id="1815501619" name="Title 1"/>
+          <p:cNvPr id="835523432" name="Title 1"/>
           <p:cNvSpPr>
             <a:spLocks noGrp="1"/>
           </p:cNvSpPr>
@@ -3102,7 +3622,7 @@
       </p:sp>
       <p:sp>
         <p:nvSpPr>
-          <p:cNvPr id="507099452" name="Text Placeholder 2"/>
+          <p:cNvPr id="409871224" name="Text Placeholder 2"/>
           <p:cNvSpPr>
             <a:spLocks noGrp="1"/>
           </p:cNvSpPr>
@@ -3170,7 +3690,7 @@
       </p:sp>
       <p:sp>
         <p:nvSpPr>
-          <p:cNvPr id="1487948774" name="Content Placeholder 3"/>
+          <p:cNvPr id="1917100699" name="Content Placeholder 3"/>
           <p:cNvSpPr>
             <a:spLocks noGrp="1"/>
           </p:cNvSpPr>
@@ -3269,7 +3789,7 @@
       </p:sp>
       <p:sp>
         <p:nvSpPr>
-          <p:cNvPr id="1005487220" name="Text Placeholder 4"/>
+          <p:cNvPr id="931730692" name="Text Placeholder 4"/>
           <p:cNvSpPr>
             <a:spLocks noGrp="1"/>
           </p:cNvSpPr>
@@ -3337,7 +3857,7 @@
       </p:sp>
       <p:sp>
         <p:nvSpPr>
-          <p:cNvPr id="1467717845" name="Content Placeholder 5"/>
+          <p:cNvPr id="655833749" name="Content Placeholder 5"/>
           <p:cNvSpPr>
             <a:spLocks noGrp="1"/>
           </p:cNvSpPr>
@@ -3436,7 +3956,7 @@
       </p:sp>
       <p:sp>
         <p:nvSpPr>
-          <p:cNvPr id="1278507655" name="Date Placeholder 6"/>
+          <p:cNvPr id="1314236922" name="Date Placeholder 6"/>
           <p:cNvSpPr>
             <a:spLocks noGrp="1"/>
           </p:cNvSpPr>
@@ -3462,7 +3982,7 @@
       </p:sp>
       <p:sp>
         <p:nvSpPr>
-          <p:cNvPr id="1034549303" name="Footer Placeholder 7"/>
+          <p:cNvPr id="793047251" name="Footer Placeholder 7"/>
           <p:cNvSpPr>
             <a:spLocks noGrp="1"/>
           </p:cNvSpPr>
@@ -3484,7 +4004,7 @@
       </p:sp>
       <p:sp>
         <p:nvSpPr>
-          <p:cNvPr id="1058526820" name="Slide Number Placeholder 8"/>
+          <p:cNvPr id="201827651" name="Slide Number Placeholder 8"/>
           <p:cNvSpPr>
             <a:spLocks noGrp="1"/>
           </p:cNvSpPr>
@@ -3535,7 +4055,7 @@
       </p:grpSpPr>
       <p:sp>
         <p:nvSpPr>
-          <p:cNvPr id="1225109233" name="Title 1"/>
+          <p:cNvPr id="252278837" name="Title 1"/>
           <p:cNvSpPr>
             <a:spLocks noGrp="1"/>
           </p:cNvSpPr>
@@ -3561,7 +4081,7 @@
       </p:sp>
       <p:sp>
         <p:nvSpPr>
-          <p:cNvPr id="401735756" name="Date Placeholder 2"/>
+          <p:cNvPr id="1846532975" name="Date Placeholder 2"/>
           <p:cNvSpPr>
             <a:spLocks noGrp="1"/>
           </p:cNvSpPr>
@@ -3587,7 +4107,7 @@
       </p:sp>
       <p:sp>
         <p:nvSpPr>
-          <p:cNvPr id="1866471429" name="Footer Placeholder 3"/>
+          <p:cNvPr id="479983463" name="Footer Placeholder 3"/>
           <p:cNvSpPr>
             <a:spLocks noGrp="1"/>
           </p:cNvSpPr>
@@ -3609,7 +4129,7 @@
       </p:sp>
       <p:sp>
         <p:nvSpPr>
-          <p:cNvPr id="1217483007" name="Slide Number Placeholder 4"/>
+          <p:cNvPr id="2138666696" name="Slide Number Placeholder 4"/>
           <p:cNvSpPr>
             <a:spLocks noGrp="1"/>
           </p:cNvSpPr>
@@ -3660,7 +4180,7 @@
       </p:grpSpPr>
       <p:sp>
         <p:nvSpPr>
-          <p:cNvPr id="1627459824" name="Date Placeholder 1"/>
+          <p:cNvPr id="2044377815" name="Date Placeholder 1"/>
           <p:cNvSpPr>
             <a:spLocks noGrp="1"/>
           </p:cNvSpPr>
@@ -3686,7 +4206,7 @@
       </p:sp>
       <p:sp>
         <p:nvSpPr>
-          <p:cNvPr id="1226108972" name="Footer Placeholder 2"/>
+          <p:cNvPr id="558634055" name="Footer Placeholder 2"/>
           <p:cNvSpPr>
             <a:spLocks noGrp="1"/>
           </p:cNvSpPr>
@@ -3708,7 +4228,7 @@
       </p:sp>
       <p:sp>
         <p:nvSpPr>
-          <p:cNvPr id="1187108408" name="Slide Number Placeholder 3"/>
+          <p:cNvPr id="639359195" name="Slide Number Placeholder 3"/>
           <p:cNvSpPr>
             <a:spLocks noGrp="1"/>
           </p:cNvSpPr>
@@ -3759,7 +4279,7 @@
       </p:grpSpPr>
       <p:sp>
         <p:nvSpPr>
-          <p:cNvPr id="602131017" name="Title 1"/>
+          <p:cNvPr id="1733399689" name="Title 1"/>
           <p:cNvSpPr>
             <a:spLocks noGrp="1"/>
           </p:cNvSpPr>
@@ -3794,7 +4314,7 @@
       </p:sp>
       <p:sp>
         <p:nvSpPr>
-          <p:cNvPr id="1205562158" name="Content Placeholder 2"/>
+          <p:cNvPr id="1111511197" name="Content Placeholder 2"/>
           <p:cNvSpPr>
             <a:spLocks noGrp="1"/>
           </p:cNvSpPr>
@@ -3893,7 +4413,7 @@
       </p:sp>
       <p:sp>
         <p:nvSpPr>
-          <p:cNvPr id="1391016601" name="Text Placeholder 3"/>
+          <p:cNvPr id="1901586751" name="Text Placeholder 3"/>
           <p:cNvSpPr>
             <a:spLocks noGrp="1"/>
           </p:cNvSpPr>
@@ -3961,7 +4481,7 @@
       </p:sp>
       <p:sp>
         <p:nvSpPr>
-          <p:cNvPr id="1118178394" name="Date Placeholder 4"/>
+          <p:cNvPr id="866997783" name="Date Placeholder 4"/>
           <p:cNvSpPr>
             <a:spLocks noGrp="1"/>
           </p:cNvSpPr>
@@ -3987,7 +4507,7 @@
       </p:sp>
       <p:sp>
         <p:nvSpPr>
-          <p:cNvPr id="655451767" name="Footer Placeholder 5"/>
+          <p:cNvPr id="31550178" name="Footer Placeholder 5"/>
           <p:cNvSpPr>
             <a:spLocks noGrp="1"/>
           </p:cNvSpPr>
@@ -4009,7 +4529,7 @@
       </p:sp>
       <p:sp>
         <p:nvSpPr>
-          <p:cNvPr id="1964095828" name="Slide Number Placeholder 6"/>
+          <p:cNvPr id="1430291745" name="Slide Number Placeholder 6"/>
           <p:cNvSpPr>
             <a:spLocks noGrp="1"/>
           </p:cNvSpPr>
@@ -4060,7 +4580,7 @@
       </p:grpSpPr>
       <p:sp>
         <p:nvSpPr>
-          <p:cNvPr id="737864801" name="Title 1"/>
+          <p:cNvPr id="1698603762" name="Title 1"/>
           <p:cNvSpPr>
             <a:spLocks noGrp="1"/>
           </p:cNvSpPr>
@@ -4095,7 +4615,7 @@
       </p:sp>
       <p:sp>
         <p:nvSpPr>
-          <p:cNvPr id="2064263997" name="Picture Placeholder 2"/>
+          <p:cNvPr id="1413458918" name="Picture Placeholder 2"/>
           <p:cNvSpPr>
             <a:spLocks noGrp="1"/>
           </p:cNvSpPr>
@@ -4159,7 +4679,7 @@
       </p:sp>
       <p:sp>
         <p:nvSpPr>
-          <p:cNvPr id="1121657667" name="Text Placeholder 3"/>
+          <p:cNvPr id="1689542784" name="Text Placeholder 3"/>
           <p:cNvSpPr>
             <a:spLocks noGrp="1"/>
           </p:cNvSpPr>
@@ -4227,7 +4747,7 @@
       </p:sp>
       <p:sp>
         <p:nvSpPr>
-          <p:cNvPr id="1207092377" name="Date Placeholder 4"/>
+          <p:cNvPr id="1681810839" name="Date Placeholder 4"/>
           <p:cNvSpPr>
             <a:spLocks noGrp="1"/>
           </p:cNvSpPr>
@@ -4253,7 +4773,7 @@
       </p:sp>
       <p:sp>
         <p:nvSpPr>
-          <p:cNvPr id="189964580" name="Footer Placeholder 5"/>
+          <p:cNvPr id="1179086214" name="Footer Placeholder 5"/>
           <p:cNvSpPr>
             <a:spLocks noGrp="1"/>
           </p:cNvSpPr>
@@ -4275,7 +4795,7 @@
       </p:sp>
       <p:sp>
         <p:nvSpPr>
-          <p:cNvPr id="423475773" name="Slide Number Placeholder 6"/>
+          <p:cNvPr id="1603222353" name="Slide Number Placeholder 6"/>
           <p:cNvSpPr>
             <a:spLocks noGrp="1"/>
           </p:cNvSpPr>
@@ -4331,7 +4851,7 @@
       </p:grpSpPr>
       <p:sp>
         <p:nvSpPr>
-          <p:cNvPr id="2084379738" name="Title Placeholder 1"/>
+          <p:cNvPr id="499706677" name="Title Placeholder 1"/>
           <p:cNvSpPr>
             <a:spLocks noGrp="1"/>
           </p:cNvSpPr>
@@ -4367,7 +4887,7 @@
       </p:sp>
       <p:sp>
         <p:nvSpPr>
-          <p:cNvPr id="844870018" name="Text Placeholder 2"/>
+          <p:cNvPr id="1436280694" name="Text Placeholder 2"/>
           <p:cNvSpPr>
             <a:spLocks noGrp="1"/>
           </p:cNvSpPr>
@@ -4443,7 +4963,7 @@
       </p:sp>
       <p:sp>
         <p:nvSpPr>
-          <p:cNvPr id="373032070" name="Date Placeholder 3"/>
+          <p:cNvPr id="72095042" name="Date Placeholder 3"/>
           <p:cNvSpPr>
             <a:spLocks noGrp="1"/>
           </p:cNvSpPr>
@@ -4487,7 +5007,7 @@
       </p:sp>
       <p:sp>
         <p:nvSpPr>
-          <p:cNvPr id="1507694767" name="Footer Placeholder 4"/>
+          <p:cNvPr id="2042954348" name="Footer Placeholder 4"/>
           <p:cNvSpPr>
             <a:spLocks noGrp="1"/>
           </p:cNvSpPr>
@@ -4527,7 +5047,7 @@
       </p:sp>
       <p:sp>
         <p:nvSpPr>
-          <p:cNvPr id="881123400" name="Slide Number Placeholder 5"/>
+          <p:cNvPr id="522629378" name="Slide Number Placeholder 5"/>
           <p:cNvSpPr>
             <a:spLocks noGrp="1"/>
           </p:cNvSpPr>
@@ -4864,7 +5384,7 @@
       </p:grpSpPr>
       <p:sp>
         <p:nvSpPr>
-          <p:cNvPr id="49691890" name="Rectangle 1"/>
+          <p:cNvPr id="2012860866" name="Rectangle 1"/>
           <p:cNvSpPr/>
           <p:nvPr/>
         </p:nvSpPr>
@@ -4911,7 +5431,7 @@
       </p:sp>
       <p:sp>
         <p:nvSpPr>
-          <p:cNvPr id="115728246" name="TextBox 2"/>
+          <p:cNvPr id="2048683105" name="TextBox 2"/>
           <p:cNvSpPr txBox="1"/>
           <p:nvPr/>
         </p:nvSpPr>
@@ -5011,7 +5531,7 @@
       </p:sp>
       <p:sp>
         <p:nvSpPr>
-          <p:cNvPr id="1546599979" name="TextBox 3"/>
+          <p:cNvPr id="857805057" name="TextBox 3"/>
           <p:cNvSpPr txBox="1"/>
           <p:nvPr/>
         </p:nvSpPr>
@@ -5049,7 +5569,7 @@
       </p:sp>
       <p:sp>
         <p:nvSpPr>
-          <p:cNvPr id="1022608161" name="TextBox 4"/>
+          <p:cNvPr id="56340838" name="TextBox 4"/>
           <p:cNvSpPr txBox="1"/>
           <p:nvPr/>
         </p:nvSpPr>
@@ -5087,7 +5607,7 @@
       </p:sp>
       <p:sp>
         <p:nvSpPr>
-          <p:cNvPr id="923934031" name="TextBox 5"/>
+          <p:cNvPr id="874046199" name="TextBox 5"/>
           <p:cNvSpPr txBox="1"/>
           <p:nvPr/>
         </p:nvSpPr>
@@ -5125,7 +5645,7 @@
       </p:sp>
       <p:sp>
         <p:nvSpPr>
-          <p:cNvPr id="1531429106" name="TextBox 6"/>
+          <p:cNvPr id="1944245544" name="TextBox 6"/>
           <p:cNvSpPr txBox="1"/>
           <p:nvPr/>
         </p:nvSpPr>
@@ -5184,7 +5704,7 @@
       </p:sp>
       <p:pic>
         <p:nvPicPr>
-          <p:cNvPr id="2112976049" name=""/>
+          <p:cNvPr id="1847368664" name=""/>
           <p:cNvPicPr>
             <a:picLocks noChangeAspect="1"/>
           </p:cNvPicPr>
@@ -5252,7 +5772,7 @@
       </p:grpSpPr>
       <p:sp>
         <p:nvSpPr>
-          <p:cNvPr id="1676348642" name="TextBox 1"/>
+          <p:cNvPr id="826075" name="TextBox 1"/>
           <p:cNvSpPr txBox="1"/>
           <p:nvPr/>
         </p:nvSpPr>
@@ -5290,7 +5810,7 @@
       </p:sp>
       <p:sp>
         <p:nvSpPr>
-          <p:cNvPr id="1311247143" name="TextBox 2"/>
+          <p:cNvPr id="248661361" name="TextBox 2"/>
           <p:cNvSpPr txBox="1"/>
           <p:nvPr/>
         </p:nvSpPr>
@@ -5328,7 +5848,7 @@
       </p:sp>
       <p:sp>
         <p:nvSpPr>
-          <p:cNvPr id="717219720" name="TextBox 3"/>
+          <p:cNvPr id="552271362" name="TextBox 3"/>
           <p:cNvSpPr txBox="1"/>
           <p:nvPr/>
         </p:nvSpPr>
@@ -5366,7 +5886,7 @@
       </p:sp>
       <p:sp>
         <p:nvSpPr>
-          <p:cNvPr id="1336203887" name="TextBox 4"/>
+          <p:cNvPr id="652432296" name="TextBox 4"/>
           <p:cNvSpPr txBox="1"/>
           <p:nvPr/>
         </p:nvSpPr>
@@ -5404,7 +5924,7 @@
       </p:sp>
       <p:sp>
         <p:nvSpPr>
-          <p:cNvPr id="904040634" name="Rounded Rectangle 5"/>
+          <p:cNvPr id="445318125" name="Rounded Rectangle 5"/>
           <p:cNvSpPr/>
           <p:nvPr/>
         </p:nvSpPr>
@@ -5455,7 +5975,7 @@
       </p:sp>
       <p:sp>
         <p:nvSpPr>
-          <p:cNvPr id="1501842993" name="TextBox 6"/>
+          <p:cNvPr id="706054698" name="TextBox 6"/>
           <p:cNvSpPr txBox="1"/>
           <p:nvPr/>
         </p:nvSpPr>
@@ -5493,7 +6013,7 @@
       </p:sp>
       <p:sp>
         <p:nvSpPr>
-          <p:cNvPr id="46023655" name="TextBox 7"/>
+          <p:cNvPr id="1725607929" name="TextBox 7"/>
           <p:cNvSpPr txBox="1"/>
           <p:nvPr/>
         </p:nvSpPr>
@@ -5531,7 +6051,7 @@
       </p:sp>
       <p:sp>
         <p:nvSpPr>
-          <p:cNvPr id="111230504" name="Rounded Rectangle 8"/>
+          <p:cNvPr id="58896913" name="Rounded Rectangle 8"/>
           <p:cNvSpPr/>
           <p:nvPr/>
         </p:nvSpPr>
@@ -5582,7 +6102,7 @@
       </p:sp>
       <p:sp>
         <p:nvSpPr>
-          <p:cNvPr id="153199827" name="TextBox 9"/>
+          <p:cNvPr id="1447933433" name="TextBox 9"/>
           <p:cNvSpPr txBox="1"/>
           <p:nvPr/>
         </p:nvSpPr>
@@ -5620,7 +6140,7 @@
       </p:sp>
       <p:sp>
         <p:nvSpPr>
-          <p:cNvPr id="1041506874" name="TextBox 10"/>
+          <p:cNvPr id="1775878615" name="TextBox 10"/>
           <p:cNvSpPr txBox="1"/>
           <p:nvPr/>
         </p:nvSpPr>
@@ -5658,7 +6178,7 @@
       </p:sp>
       <p:sp>
         <p:nvSpPr>
-          <p:cNvPr id="278203836" name="Rounded Rectangle 11"/>
+          <p:cNvPr id="1411016306" name="Rounded Rectangle 11"/>
           <p:cNvSpPr/>
           <p:nvPr/>
         </p:nvSpPr>
@@ -5709,7 +6229,7 @@
       </p:sp>
       <p:sp>
         <p:nvSpPr>
-          <p:cNvPr id="1312123176" name="TextBox 12"/>
+          <p:cNvPr id="59647099" name="TextBox 12"/>
           <p:cNvSpPr txBox="1"/>
           <p:nvPr/>
         </p:nvSpPr>
@@ -5747,7 +6267,7 @@
       </p:sp>
       <p:sp>
         <p:nvSpPr>
-          <p:cNvPr id="694675171" name="TextBox 13"/>
+          <p:cNvPr id="792195968" name="TextBox 13"/>
           <p:cNvSpPr txBox="1"/>
           <p:nvPr/>
         </p:nvSpPr>
@@ -5785,7 +6305,7 @@
       </p:sp>
       <p:sp>
         <p:nvSpPr>
-          <p:cNvPr id="494969632" name="Rounded Rectangle 14"/>
+          <p:cNvPr id="1563950887" name="Rounded Rectangle 14"/>
           <p:cNvSpPr/>
           <p:nvPr/>
         </p:nvSpPr>
@@ -5836,7 +6356,7 @@
       </p:sp>
       <p:sp>
         <p:nvSpPr>
-          <p:cNvPr id="958067999" name="TextBox 15"/>
+          <p:cNvPr id="1044473996" name="TextBox 15"/>
           <p:cNvSpPr txBox="1"/>
           <p:nvPr/>
         </p:nvSpPr>
@@ -5874,7 +6394,7 @@
       </p:sp>
       <p:sp>
         <p:nvSpPr>
-          <p:cNvPr id="1977251672" name="TextBox 16"/>
+          <p:cNvPr id="1289936245" name="TextBox 16"/>
           <p:cNvSpPr txBox="1"/>
           <p:nvPr/>
         </p:nvSpPr>
@@ -5912,7 +6432,7 @@
       </p:sp>
       <p:sp>
         <p:nvSpPr>
-          <p:cNvPr id="377716283" name="Rounded Rectangle 17"/>
+          <p:cNvPr id="788874249" name="Rounded Rectangle 17"/>
           <p:cNvSpPr/>
           <p:nvPr/>
         </p:nvSpPr>
@@ -5963,7 +6483,7 @@
       </p:sp>
       <p:sp>
         <p:nvSpPr>
-          <p:cNvPr id="228053415" name="TextBox 18"/>
+          <p:cNvPr id="1663243330" name="TextBox 18"/>
           <p:cNvSpPr txBox="1"/>
           <p:nvPr/>
         </p:nvSpPr>
@@ -6001,7 +6521,7 @@
       </p:sp>
       <p:sp>
         <p:nvSpPr>
-          <p:cNvPr id="1937679787" name="TextBox 19"/>
+          <p:cNvPr id="2036463337" name="TextBox 19"/>
           <p:cNvSpPr txBox="1"/>
           <p:nvPr/>
         </p:nvSpPr>
@@ -6039,7 +6559,7 @@
       </p:sp>
       <p:sp>
         <p:nvSpPr>
-          <p:cNvPr id="880843390" name="Rounded Rectangle 20"/>
+          <p:cNvPr id="1719467178" name="Rounded Rectangle 20"/>
           <p:cNvSpPr/>
           <p:nvPr/>
         </p:nvSpPr>
@@ -6090,7 +6610,7 @@
       </p:sp>
       <p:sp>
         <p:nvSpPr>
-          <p:cNvPr id="593815613" name="TextBox 21"/>
+          <p:cNvPr id="429687362" name="TextBox 21"/>
           <p:cNvSpPr txBox="1"/>
           <p:nvPr/>
         </p:nvSpPr>
@@ -6128,7 +6648,7 @@
       </p:sp>
       <p:sp>
         <p:nvSpPr>
-          <p:cNvPr id="1557525937" name="TextBox 22"/>
+          <p:cNvPr id="2095672876" name="TextBox 22"/>
           <p:cNvSpPr txBox="1"/>
           <p:nvPr/>
         </p:nvSpPr>
@@ -6166,7 +6686,7 @@
       </p:sp>
       <p:pic>
         <p:nvPicPr>
-          <p:cNvPr id="1495104362" name="Picture 23" descr="landing.png"/>
+          <p:cNvPr id="1973243935" name="Picture 23" descr="landing.png"/>
           <p:cNvPicPr>
             <a:picLocks noChangeAspect="1"/>
           </p:cNvPicPr>
@@ -6188,7 +6708,7 @@
       </p:pic>
       <p:pic>
         <p:nvPicPr>
-          <p:cNvPr id="911778164" name="Picture 24" descr="login.png"/>
+          <p:cNvPr id="415845152" name="Picture 24" descr="login.png"/>
           <p:cNvPicPr>
             <a:picLocks noChangeAspect="1"/>
           </p:cNvPicPr>
@@ -6250,7 +6770,7 @@
       </p:grpSpPr>
       <p:sp>
         <p:nvSpPr>
-          <p:cNvPr id="685949611" name="TextBox 1"/>
+          <p:cNvPr id="2025366527" name="TextBox 1"/>
           <p:cNvSpPr txBox="1"/>
           <p:nvPr/>
         </p:nvSpPr>
@@ -6288,7 +6808,7 @@
       </p:sp>
       <p:sp>
         <p:nvSpPr>
-          <p:cNvPr id="1136458160" name="TextBox 2"/>
+          <p:cNvPr id="1106543943" name="TextBox 2"/>
           <p:cNvSpPr txBox="1"/>
           <p:nvPr/>
         </p:nvSpPr>
@@ -6326,7 +6846,7 @@
       </p:sp>
       <p:sp>
         <p:nvSpPr>
-          <p:cNvPr id="1847972985" name="TextBox 3"/>
+          <p:cNvPr id="846972696" name="TextBox 3"/>
           <p:cNvSpPr txBox="1"/>
           <p:nvPr/>
         </p:nvSpPr>
@@ -6364,7 +6884,7 @@
       </p:sp>
       <p:sp>
         <p:nvSpPr>
-          <p:cNvPr id="904542495" name="TextBox 4"/>
+          <p:cNvPr id="1673379529" name="TextBox 4"/>
           <p:cNvSpPr txBox="1"/>
           <p:nvPr/>
         </p:nvSpPr>
@@ -6402,7 +6922,7 @@
       </p:sp>
       <p:sp>
         <p:nvSpPr>
-          <p:cNvPr id="854447051" name="TextBox 5"/>
+          <p:cNvPr id="1386090609" name="TextBox 5"/>
           <p:cNvSpPr txBox="1"/>
           <p:nvPr/>
         </p:nvSpPr>
@@ -6570,7 +7090,7 @@
       </p:grpSpPr>
       <p:sp>
         <p:nvSpPr>
-          <p:cNvPr id="1309580545" name="TextBox 1"/>
+          <p:cNvPr id="1255418387" name="TextBox 1"/>
           <p:cNvSpPr txBox="1"/>
           <p:nvPr/>
         </p:nvSpPr>
@@ -6608,7 +7128,7 @@
       </p:sp>
       <p:sp>
         <p:nvSpPr>
-          <p:cNvPr id="43262970" name="TextBox 2"/>
+          <p:cNvPr id="1005764441" name="TextBox 2"/>
           <p:cNvSpPr txBox="1"/>
           <p:nvPr/>
         </p:nvSpPr>
@@ -6646,7 +7166,7 @@
       </p:sp>
       <p:sp>
         <p:nvSpPr>
-          <p:cNvPr id="741662914" name="TextBox 3"/>
+          <p:cNvPr id="117800038" name="TextBox 3"/>
           <p:cNvSpPr txBox="1"/>
           <p:nvPr/>
         </p:nvSpPr>
@@ -6684,7 +7204,7 @@
       </p:sp>
       <p:sp>
         <p:nvSpPr>
-          <p:cNvPr id="1681331490" name="TextBox 4"/>
+          <p:cNvPr id="2061623090" name="TextBox 4"/>
           <p:cNvSpPr txBox="1"/>
           <p:nvPr/>
         </p:nvSpPr>
@@ -6722,7 +7242,7 @@
       </p:sp>
       <p:sp>
         <p:nvSpPr>
-          <p:cNvPr id="1243590314" name="TextBox 5"/>
+          <p:cNvPr id="1397790584" name="TextBox 5"/>
           <p:cNvSpPr txBox="1"/>
           <p:nvPr/>
         </p:nvSpPr>
@@ -6742,30 +7262,50 @@
           </a:bodyPr>
           <a:lstStyle/>
           <a:p>
-            <a:r>
+            <a:pPr>
+              <a:defRPr/>
+            </a:pPr>
+            <a:r>
+              <a:rPr/>
               <a:t>▪ Deployed online using standard web hosting services.</a:t>
             </a:r>
-          </a:p>
-          <a:p>
-            <a:r>
+            <a:endParaRPr/>
+          </a:p>
+          <a:p>
+            <a:pPr>
+              <a:defRPr/>
+            </a:pPr>
+            <a:r>
+              <a:rPr/>
               <a:t>▪ Frontend is a Vue 3 Single Page Application.</a:t>
             </a:r>
-          </a:p>
-          <a:p>
-            <a:r>
+            <a:endParaRPr/>
+          </a:p>
+          <a:p>
+            <a:pPr>
+              <a:defRPr/>
+            </a:pPr>
+            <a:r>
+              <a:rPr/>
               <a:t>▪ Backend is a Node.js REST API.</a:t>
             </a:r>
-          </a:p>
-          <a:p>
-            <a:r>
+            <a:endParaRPr/>
+          </a:p>
+          <a:p>
+            <a:pPr>
+              <a:defRPr/>
+            </a:pPr>
+            <a:r>
+              <a:rPr/>
               <a:t>▪ Database is MySQL/MariaDB.</a:t>
             </a:r>
-          </a:p>
-        </p:txBody>
-      </p:sp>
-      <p:sp>
-        <p:nvSpPr>
-          <p:cNvPr id="748444850" name="Rounded Rectangle 6"/>
+            <a:endParaRPr/>
+          </a:p>
+        </p:txBody>
+      </p:sp>
+      <p:sp>
+        <p:nvSpPr>
+          <p:cNvPr id="697152595" name="Rounded Rectangle 6"/>
           <p:cNvSpPr/>
           <p:nvPr/>
         </p:nvSpPr>
@@ -6814,7 +7354,7 @@
       </p:sp>
       <p:sp>
         <p:nvSpPr>
-          <p:cNvPr id="1533312924" name="TextBox 7"/>
+          <p:cNvPr id="1905118944" name="TextBox 7"/>
           <p:cNvSpPr txBox="1"/>
           <p:nvPr/>
         </p:nvSpPr>
@@ -6852,14 +7392,14 @@
       </p:sp>
       <p:sp>
         <p:nvSpPr>
-          <p:cNvPr id="252151753" name="TextBox 8"/>
+          <p:cNvPr id="846801291" name="TextBox 8"/>
           <p:cNvSpPr txBox="1"/>
           <p:nvPr/>
         </p:nvSpPr>
         <p:spPr bwMode="auto">
           <a:xfrm>
             <a:off x="7498080" y="2331720"/>
-            <a:ext cx="3611880" cy="3017519"/>
+            <a:ext cx="3612240" cy="823320"/>
           </a:xfrm>
           <a:prstGeom prst="rect">
             <a:avLst/>
@@ -6872,19 +7412,58 @@
           </a:bodyPr>
           <a:lstStyle/>
           <a:p>
-            <a:r>
+            <a:pPr>
+              <a:defRPr/>
+            </a:pPr>
+            <a:r>
+              <a:rPr>
+                <a:solidFill>
+                  <a:schemeClr val="bg1"/>
+                </a:solidFill>
+              </a:rPr>
               <a:t>Frontend: Vue 3</a:t>
             </a:r>
-          </a:p>
-          <a:p>
-            <a:r>
+            <a:endParaRPr>
+              <a:solidFill>
+                <a:schemeClr val="bg1"/>
+              </a:solidFill>
+            </a:endParaRPr>
+          </a:p>
+          <a:p>
+            <a:pPr>
+              <a:defRPr/>
+            </a:pPr>
+            <a:r>
+              <a:rPr>
+                <a:solidFill>
+                  <a:schemeClr val="bg1"/>
+                </a:solidFill>
+              </a:rPr>
               <a:t>Backend: Node.js / Express</a:t>
             </a:r>
-          </a:p>
-          <a:p>
-            <a:r>
+            <a:endParaRPr>
+              <a:solidFill>
+                <a:schemeClr val="bg1"/>
+              </a:solidFill>
+            </a:endParaRPr>
+          </a:p>
+          <a:p>
+            <a:pPr>
+              <a:defRPr/>
+            </a:pPr>
+            <a:r>
+              <a:rPr>
+                <a:solidFill>
+                  <a:schemeClr val="bg1"/>
+                </a:solidFill>
+              </a:rPr>
               <a:t>Database: MySQL</a:t>
             </a:r>
+            <a:endParaRPr>
+              <a:solidFill>
+                <a:schemeClr val="bg1"/>
+              </a:solidFill>
+            </a:endParaRPr>
           </a:p>
         </p:txBody>
       </p:sp>
@@ -6930,7 +7509,7 @@
       </p:grpSpPr>
       <p:sp>
         <p:nvSpPr>
-          <p:cNvPr id="125266339" name="TextBox 1"/>
+          <p:cNvPr id="1642834265" name="TextBox 1"/>
           <p:cNvSpPr txBox="1"/>
           <p:nvPr/>
         </p:nvSpPr>
@@ -6968,7 +7547,7 @@
       </p:sp>
       <p:sp>
         <p:nvSpPr>
-          <p:cNvPr id="1092407583" name="TextBox 2"/>
+          <p:cNvPr id="850317392" name="TextBox 2"/>
           <p:cNvSpPr txBox="1"/>
           <p:nvPr/>
         </p:nvSpPr>
@@ -7006,7 +7585,7 @@
       </p:sp>
       <p:sp>
         <p:nvSpPr>
-          <p:cNvPr id="1094884607" name="TextBox 3"/>
+          <p:cNvPr id="1684288658" name="TextBox 3"/>
           <p:cNvSpPr txBox="1"/>
           <p:nvPr/>
         </p:nvSpPr>
@@ -7044,7 +7623,7 @@
       </p:sp>
       <p:sp>
         <p:nvSpPr>
-          <p:cNvPr id="1840293471" name="TextBox 4"/>
+          <p:cNvPr id="1846422224" name="TextBox 4"/>
           <p:cNvSpPr txBox="1"/>
           <p:nvPr/>
         </p:nvSpPr>
@@ -7082,7 +7661,7 @@
       </p:sp>
       <p:sp>
         <p:nvSpPr>
-          <p:cNvPr id="486341996" name="TextBox 5"/>
+          <p:cNvPr id="650091951" name="TextBox 5"/>
           <p:cNvSpPr txBox="1"/>
           <p:nvPr/>
         </p:nvSpPr>
@@ -7168,7 +7747,7 @@
       </p:sp>
       <p:sp>
         <p:nvSpPr>
-          <p:cNvPr id="891221895" name="TextBox 6"/>
+          <p:cNvPr id="1426403560" name="TextBox 6"/>
           <p:cNvSpPr txBox="1"/>
           <p:nvPr/>
         </p:nvSpPr>
@@ -7206,7 +7785,7 @@
       </p:sp>
       <p:sp>
         <p:nvSpPr>
-          <p:cNvPr id="835874884" name="TextBox 7"/>
+          <p:cNvPr id="1966362420" name="TextBox 7"/>
           <p:cNvSpPr txBox="1"/>
           <p:nvPr/>
         </p:nvSpPr>
@@ -7353,7 +7932,7 @@
       </p:grpSpPr>
       <p:sp>
         <p:nvSpPr>
-          <p:cNvPr id="1041411731" name="TextBox 1"/>
+          <p:cNvPr id="490519196" name="TextBox 1"/>
           <p:cNvSpPr txBox="1"/>
           <p:nvPr/>
         </p:nvSpPr>
@@ -7391,7 +7970,7 @@
       </p:sp>
       <p:sp>
         <p:nvSpPr>
-          <p:cNvPr id="2138659585" name="TextBox 2"/>
+          <p:cNvPr id="2000160254" name="TextBox 2"/>
           <p:cNvSpPr txBox="1"/>
           <p:nvPr/>
         </p:nvSpPr>
@@ -7429,7 +8008,7 @@
       </p:sp>
       <p:sp>
         <p:nvSpPr>
-          <p:cNvPr id="821555438" name="TextBox 3"/>
+          <p:cNvPr id="897463498" name="TextBox 3"/>
           <p:cNvSpPr txBox="1"/>
           <p:nvPr/>
         </p:nvSpPr>
@@ -7488,7 +8067,7 @@
       </p:sp>
       <p:sp>
         <p:nvSpPr>
-          <p:cNvPr id="1478107619" name="TextBox 4"/>
+          <p:cNvPr id="621370184" name="TextBox 4"/>
           <p:cNvSpPr txBox="1"/>
           <p:nvPr/>
         </p:nvSpPr>
@@ -7541,18 +8120,25 @@
 </file>
 
 <file path=ppt/slides/slide15.xml><?xml version="1.0" encoding="utf-8"?>
-<p:sld xmlns:a="http://schemas.openxmlformats.org/drawingml/2006/main" xmlns:p="http://schemas.openxmlformats.org/presentationml/2006/main" xmlns:r="http://schemas.openxmlformats.org/officeDocument/2006/relationships">
-  <p:cSld>
+<p:sld xmlns:a="http://schemas.openxmlformats.org/drawingml/2006/main" xmlns:r="http://schemas.openxmlformats.org/officeDocument/2006/relationships" xmlns:p="http://schemas.openxmlformats.org/presentationml/2006/main" xmlns:m="http://schemas.openxmlformats.org/officeDocument/2006/math" xmlns:w="http://schemas.openxmlformats.org/wordprocessingml/2006/main" xmlns:mc="http://schemas.openxmlformats.org/markup-compatibility/2006" showMasterPhAnim="0" showMasterSp="1" show="1">
+  <p:cSld name="">
     <p:spTree>
       <p:nvGrpSpPr>
         <p:cNvPr id="1" name=""/>
         <p:cNvGrpSpPr/>
         <p:nvPr/>
       </p:nvGrpSpPr>
-      <p:grpSpPr/>
-      <p:sp>
-        <p:nvSpPr>
-          <p:cNvPr id="2" name="Title 1"/>
+      <p:grpSpPr bwMode="auto">
+        <a:xfrm>
+          <a:off x="0" y="0"/>
+          <a:ext cx="0" cy="0"/>
+          <a:chOff x="0" y="0"/>
+          <a:chExt cx="0" cy="0"/>
+        </a:xfrm>
+      </p:grpSpPr>
+      <p:sp>
+        <p:nvSpPr>
+          <p:cNvPr id="630822969" name="Title 1"/>
           <p:cNvSpPr>
             <a:spLocks noGrp="1"/>
           </p:cNvSpPr>
@@ -7560,32 +8146,35 @@
             <p:ph type="title"/>
           </p:nvPr>
         </p:nvSpPr>
-        <p:spPr/>
+        <p:spPr bwMode="auto"/>
         <p:txBody>
           <a:bodyPr/>
           <a:lstStyle/>
           <a:p>
-            <a:r>
+            <a:pPr>
+              <a:defRPr/>
+            </a:pPr>
+            <a:r>
+              <a:rPr/>
               <a:t>Application Screens: Dashboard</a:t>
             </a:r>
+            <a:endParaRPr/>
           </a:p>
         </p:txBody>
       </p:sp>
       <p:pic>
         <p:nvPicPr>
-          <p:cNvPr id="3" name="Picture 2" descr="Dashboard.png"/>
+          <p:cNvPr id="1929778622" name="Picture 2" descr="Dashboard.png"/>
           <p:cNvPicPr>
             <a:picLocks noChangeAspect="1"/>
           </p:cNvPicPr>
           <p:nvPr/>
         </p:nvPicPr>
-        <p:blipFill>
-          <a:blip r:embed="rId2"/>
-          <a:stretch>
-            <a:fillRect/>
-          </a:stretch>
+        <p:blipFill rotWithShape="1">
+          <a:blip r:embed="rId3"/>
+          <a:stretch/>
         </p:blipFill>
-        <p:spPr>
+        <p:spPr bwMode="auto">
           <a:xfrm>
             <a:off x="457200" y="1371600"/>
             <a:ext cx="8229600" cy="3709749"/>
@@ -7600,22 +8189,37 @@
   <p:clrMapOvr>
     <a:masterClrMapping/>
   </p:clrMapOvr>
+  <mc:AlternateContent xmlns:mc="http://schemas.openxmlformats.org/markup-compatibility/2006">
+    <mc:Choice xmlns:p159="http://schemas.microsoft.com/office/powerpoint/2015/09/main" xmlns:p14="http://schemas.microsoft.com/office/powerpoint/2010/main" Requires="p159">
+      <p:transition p14:dur="500" advClick="1"/>
+    </mc:Choice>
+    <mc:Fallback>
+      <p:transition advClick="1"/>
+    </mc:Fallback>
+  </mc:AlternateContent>
 </p:sld>
 </file>
 
 <file path=ppt/slides/slide16.xml><?xml version="1.0" encoding="utf-8"?>
-<p:sld xmlns:a="http://schemas.openxmlformats.org/drawingml/2006/main" xmlns:p="http://schemas.openxmlformats.org/presentationml/2006/main" xmlns:r="http://schemas.openxmlformats.org/officeDocument/2006/relationships">
-  <p:cSld>
+<p:sld xmlns:a="http://schemas.openxmlformats.org/drawingml/2006/main" xmlns:r="http://schemas.openxmlformats.org/officeDocument/2006/relationships" xmlns:p="http://schemas.openxmlformats.org/presentationml/2006/main" xmlns:m="http://schemas.openxmlformats.org/officeDocument/2006/math" xmlns:w="http://schemas.openxmlformats.org/wordprocessingml/2006/main" xmlns:mc="http://schemas.openxmlformats.org/markup-compatibility/2006" showMasterPhAnim="0" showMasterSp="1" show="1">
+  <p:cSld name="">
     <p:spTree>
       <p:nvGrpSpPr>
         <p:cNvPr id="1" name=""/>
         <p:cNvGrpSpPr/>
         <p:nvPr/>
       </p:nvGrpSpPr>
-      <p:grpSpPr/>
-      <p:sp>
-        <p:nvSpPr>
-          <p:cNvPr id="2" name="Title 1"/>
+      <p:grpSpPr bwMode="auto">
+        <a:xfrm>
+          <a:off x="0" y="0"/>
+          <a:ext cx="0" cy="0"/>
+          <a:chOff x="0" y="0"/>
+          <a:chExt cx="0" cy="0"/>
+        </a:xfrm>
+      </p:grpSpPr>
+      <p:sp>
+        <p:nvSpPr>
+          <p:cNvPr id="989651832" name="Title 1"/>
           <p:cNvSpPr>
             <a:spLocks noGrp="1"/>
           </p:cNvSpPr>
@@ -7623,32 +8227,35 @@
             <p:ph type="title"/>
           </p:nvPr>
         </p:nvSpPr>
-        <p:spPr/>
+        <p:spPr bwMode="auto"/>
         <p:txBody>
           <a:bodyPr/>
           <a:lstStyle/>
           <a:p>
-            <a:r>
+            <a:pPr>
+              <a:defRPr/>
+            </a:pPr>
+            <a:r>
+              <a:rPr/>
               <a:t>Application Screens: Donor Management</a:t>
             </a:r>
+            <a:endParaRPr/>
           </a:p>
         </p:txBody>
       </p:sp>
       <p:pic>
         <p:nvPicPr>
-          <p:cNvPr id="3" name="Picture 2" descr="Donors.png"/>
+          <p:cNvPr id="842267478" name="Picture 2" descr="Donors.png"/>
           <p:cNvPicPr>
             <a:picLocks noChangeAspect="1"/>
           </p:cNvPicPr>
           <p:nvPr/>
         </p:nvPicPr>
-        <p:blipFill>
-          <a:blip r:embed="rId2"/>
-          <a:stretch>
-            <a:fillRect/>
-          </a:stretch>
+        <p:blipFill rotWithShape="1">
+          <a:blip r:embed="rId3"/>
+          <a:stretch/>
         </p:blipFill>
-        <p:spPr>
+        <p:spPr bwMode="auto">
           <a:xfrm>
             <a:off x="457200" y="1371600"/>
             <a:ext cx="8229600" cy="3709749"/>
@@ -7663,22 +8270,37 @@
   <p:clrMapOvr>
     <a:masterClrMapping/>
   </p:clrMapOvr>
+  <mc:AlternateContent xmlns:mc="http://schemas.openxmlformats.org/markup-compatibility/2006">
+    <mc:Choice xmlns:p159="http://schemas.microsoft.com/office/powerpoint/2015/09/main" xmlns:p14="http://schemas.microsoft.com/office/powerpoint/2010/main" Requires="p159">
+      <p:transition p14:dur="500" advClick="1"/>
+    </mc:Choice>
+    <mc:Fallback>
+      <p:transition advClick="1"/>
+    </mc:Fallback>
+  </mc:AlternateContent>
 </p:sld>
 </file>
 
 <file path=ppt/slides/slide17.xml><?xml version="1.0" encoding="utf-8"?>
-<p:sld xmlns:a="http://schemas.openxmlformats.org/drawingml/2006/main" xmlns:p="http://schemas.openxmlformats.org/presentationml/2006/main" xmlns:r="http://schemas.openxmlformats.org/officeDocument/2006/relationships">
-  <p:cSld>
+<p:sld xmlns:a="http://schemas.openxmlformats.org/drawingml/2006/main" xmlns:r="http://schemas.openxmlformats.org/officeDocument/2006/relationships" xmlns:p="http://schemas.openxmlformats.org/presentationml/2006/main" xmlns:m="http://schemas.openxmlformats.org/officeDocument/2006/math" xmlns:w="http://schemas.openxmlformats.org/wordprocessingml/2006/main" xmlns:mc="http://schemas.openxmlformats.org/markup-compatibility/2006" showMasterPhAnim="0" showMasterSp="1" show="1">
+  <p:cSld name="">
     <p:spTree>
       <p:nvGrpSpPr>
         <p:cNvPr id="1" name=""/>
         <p:cNvGrpSpPr/>
         <p:nvPr/>
       </p:nvGrpSpPr>
-      <p:grpSpPr/>
-      <p:sp>
-        <p:nvSpPr>
-          <p:cNvPr id="2" name="Title 1"/>
+      <p:grpSpPr bwMode="auto">
+        <a:xfrm>
+          <a:off x="0" y="0"/>
+          <a:ext cx="0" cy="0"/>
+          <a:chOff x="0" y="0"/>
+          <a:chExt cx="0" cy="0"/>
+        </a:xfrm>
+      </p:grpSpPr>
+      <p:sp>
+        <p:nvSpPr>
+          <p:cNvPr id="1107681076" name="Title 1"/>
           <p:cNvSpPr>
             <a:spLocks noGrp="1"/>
           </p:cNvSpPr>
@@ -7686,32 +8308,35 @@
             <p:ph type="title"/>
           </p:nvPr>
         </p:nvSpPr>
-        <p:spPr/>
+        <p:spPr bwMode="auto"/>
         <p:txBody>
           <a:bodyPr/>
           <a:lstStyle/>
           <a:p>
-            <a:r>
+            <a:pPr>
+              <a:defRPr/>
+            </a:pPr>
+            <a:r>
+              <a:rPr/>
               <a:t>Application Screens: Camp Register</a:t>
             </a:r>
+            <a:endParaRPr/>
           </a:p>
         </p:txBody>
       </p:sp>
       <p:pic>
         <p:nvPicPr>
-          <p:cNvPr id="3" name="Picture 2" descr="Register.png"/>
+          <p:cNvPr id="1000429511" name="Picture 2" descr="Register.png"/>
           <p:cNvPicPr>
             <a:picLocks noChangeAspect="1"/>
           </p:cNvPicPr>
           <p:nvPr/>
         </p:nvPicPr>
-        <p:blipFill>
-          <a:blip r:embed="rId2"/>
-          <a:stretch>
-            <a:fillRect/>
-          </a:stretch>
+        <p:blipFill rotWithShape="1">
+          <a:blip r:embed="rId3"/>
+          <a:stretch/>
         </p:blipFill>
-        <p:spPr>
+        <p:spPr bwMode="auto">
           <a:xfrm>
             <a:off x="457200" y="1371600"/>
             <a:ext cx="8229600" cy="3709749"/>
@@ -7726,22 +8351,37 @@
   <p:clrMapOvr>
     <a:masterClrMapping/>
   </p:clrMapOvr>
+  <mc:AlternateContent xmlns:mc="http://schemas.openxmlformats.org/markup-compatibility/2006">
+    <mc:Choice xmlns:p159="http://schemas.microsoft.com/office/powerpoint/2015/09/main" xmlns:p14="http://schemas.microsoft.com/office/powerpoint/2010/main" Requires="p159">
+      <p:transition p14:dur="500" advClick="1"/>
+    </mc:Choice>
+    <mc:Fallback>
+      <p:transition advClick="1"/>
+    </mc:Fallback>
+  </mc:AlternateContent>
 </p:sld>
 </file>
 
 <file path=ppt/slides/slide18.xml><?xml version="1.0" encoding="utf-8"?>
-<p:sld xmlns:a="http://schemas.openxmlformats.org/drawingml/2006/main" xmlns:p="http://schemas.openxmlformats.org/presentationml/2006/main" xmlns:r="http://schemas.openxmlformats.org/officeDocument/2006/relationships">
-  <p:cSld>
+<p:sld xmlns:a="http://schemas.openxmlformats.org/drawingml/2006/main" xmlns:r="http://schemas.openxmlformats.org/officeDocument/2006/relationships" xmlns:p="http://schemas.openxmlformats.org/presentationml/2006/main" xmlns:m="http://schemas.openxmlformats.org/officeDocument/2006/math" xmlns:w="http://schemas.openxmlformats.org/wordprocessingml/2006/main" xmlns:mc="http://schemas.openxmlformats.org/markup-compatibility/2006" showMasterPhAnim="0" showMasterSp="1" show="1">
+  <p:cSld name="">
     <p:spTree>
       <p:nvGrpSpPr>
         <p:cNvPr id="1" name=""/>
         <p:cNvGrpSpPr/>
         <p:nvPr/>
       </p:nvGrpSpPr>
-      <p:grpSpPr/>
-      <p:sp>
-        <p:nvSpPr>
-          <p:cNvPr id="2" name="Title 1"/>
+      <p:grpSpPr bwMode="auto">
+        <a:xfrm>
+          <a:off x="0" y="0"/>
+          <a:ext cx="0" cy="0"/>
+          <a:chOff x="0" y="0"/>
+          <a:chExt cx="0" cy="0"/>
+        </a:xfrm>
+      </p:grpSpPr>
+      <p:sp>
+        <p:nvSpPr>
+          <p:cNvPr id="992262642" name="Title 1"/>
           <p:cNvSpPr>
             <a:spLocks noGrp="1"/>
           </p:cNvSpPr>
@@ -7749,32 +8389,35 @@
             <p:ph type="title"/>
           </p:nvPr>
         </p:nvSpPr>
-        <p:spPr/>
+        <p:spPr bwMode="auto"/>
         <p:txBody>
           <a:bodyPr/>
           <a:lstStyle/>
           <a:p>
-            <a:r>
+            <a:pPr>
+              <a:defRPr/>
+            </a:pPr>
+            <a:r>
+              <a:rPr/>
               <a:t>Application Screens: Budget &amp; Donations</a:t>
             </a:r>
+            <a:endParaRPr/>
           </a:p>
         </p:txBody>
       </p:sp>
       <p:pic>
         <p:nvPicPr>
-          <p:cNvPr id="3" name="Picture 2" descr="Budget.png"/>
+          <p:cNvPr id="1153507404" name="Picture 2" descr="Budget.png"/>
           <p:cNvPicPr>
             <a:picLocks noChangeAspect="1"/>
           </p:cNvPicPr>
           <p:nvPr/>
         </p:nvPicPr>
-        <p:blipFill>
-          <a:blip r:embed="rId2"/>
-          <a:stretch>
-            <a:fillRect/>
-          </a:stretch>
+        <p:blipFill rotWithShape="1">
+          <a:blip r:embed="rId3"/>
+          <a:stretch/>
         </p:blipFill>
-        <p:spPr>
+        <p:spPr bwMode="auto">
           <a:xfrm>
             <a:off x="457200" y="1371600"/>
             <a:ext cx="8229600" cy="3709749"/>
@@ -7789,22 +8432,37 @@
   <p:clrMapOvr>
     <a:masterClrMapping/>
   </p:clrMapOvr>
+  <mc:AlternateContent xmlns:mc="http://schemas.openxmlformats.org/markup-compatibility/2006">
+    <mc:Choice xmlns:p159="http://schemas.microsoft.com/office/powerpoint/2015/09/main" xmlns:p14="http://schemas.microsoft.com/office/powerpoint/2010/main" Requires="p159">
+      <p:transition p14:dur="500" advClick="1"/>
+    </mc:Choice>
+    <mc:Fallback>
+      <p:transition advClick="1"/>
+    </mc:Fallback>
+  </mc:AlternateContent>
 </p:sld>
 </file>
 
 <file path=ppt/slides/slide19.xml><?xml version="1.0" encoding="utf-8"?>
-<p:sld xmlns:a="http://schemas.openxmlformats.org/drawingml/2006/main" xmlns:p="http://schemas.openxmlformats.org/presentationml/2006/main" xmlns:r="http://schemas.openxmlformats.org/officeDocument/2006/relationships">
-  <p:cSld>
+<p:sld xmlns:a="http://schemas.openxmlformats.org/drawingml/2006/main" xmlns:r="http://schemas.openxmlformats.org/officeDocument/2006/relationships" xmlns:p="http://schemas.openxmlformats.org/presentationml/2006/main" xmlns:m="http://schemas.openxmlformats.org/officeDocument/2006/math" xmlns:w="http://schemas.openxmlformats.org/wordprocessingml/2006/main" xmlns:mc="http://schemas.openxmlformats.org/markup-compatibility/2006" showMasterPhAnim="0" showMasterSp="1" show="1">
+  <p:cSld name="">
     <p:spTree>
       <p:nvGrpSpPr>
         <p:cNvPr id="1" name=""/>
         <p:cNvGrpSpPr/>
         <p:nvPr/>
       </p:nvGrpSpPr>
-      <p:grpSpPr/>
-      <p:sp>
-        <p:nvSpPr>
-          <p:cNvPr id="2" name="Title 1"/>
+      <p:grpSpPr bwMode="auto">
+        <a:xfrm>
+          <a:off x="0" y="0"/>
+          <a:ext cx="0" cy="0"/>
+          <a:chOff x="0" y="0"/>
+          <a:chExt cx="0" cy="0"/>
+        </a:xfrm>
+      </p:grpSpPr>
+      <p:sp>
+        <p:nvSpPr>
+          <p:cNvPr id="782000716" name="Title 1"/>
           <p:cNvSpPr>
             <a:spLocks noGrp="1"/>
           </p:cNvSpPr>
@@ -7812,32 +8470,35 @@
             <p:ph type="title"/>
           </p:nvPr>
         </p:nvSpPr>
-        <p:spPr/>
+        <p:spPr bwMode="auto"/>
         <p:txBody>
           <a:bodyPr/>
           <a:lstStyle/>
           <a:p>
-            <a:r>
+            <a:pPr>
+              <a:defRPr/>
+            </a:pPr>
+            <a:r>
+              <a:rPr/>
               <a:t>Application Screens: Messaging &amp; Templates</a:t>
             </a:r>
+            <a:endParaRPr/>
           </a:p>
         </p:txBody>
       </p:sp>
       <p:pic>
         <p:nvPicPr>
-          <p:cNvPr id="3" name="Picture 2" descr="Messages.png"/>
+          <p:cNvPr id="2138997253" name="Picture 2" descr="Messages.png"/>
           <p:cNvPicPr>
             <a:picLocks noChangeAspect="1"/>
           </p:cNvPicPr>
           <p:nvPr/>
         </p:nvPicPr>
-        <p:blipFill>
-          <a:blip r:embed="rId2"/>
-          <a:stretch>
-            <a:fillRect/>
-          </a:stretch>
+        <p:blipFill rotWithShape="1">
+          <a:blip r:embed="rId3"/>
+          <a:stretch/>
         </p:blipFill>
-        <p:spPr>
+        <p:spPr bwMode="auto">
           <a:xfrm>
             <a:off x="457200" y="1371600"/>
             <a:ext cx="8229600" cy="3709749"/>
@@ -7852,6 +8513,14 @@
   <p:clrMapOvr>
     <a:masterClrMapping/>
   </p:clrMapOvr>
+  <mc:AlternateContent xmlns:mc="http://schemas.openxmlformats.org/markup-compatibility/2006">
+    <mc:Choice xmlns:p159="http://schemas.microsoft.com/office/powerpoint/2015/09/main" xmlns:p14="http://schemas.microsoft.com/office/powerpoint/2010/main" Requires="p159">
+      <p:transition p14:dur="500" advClick="1"/>
+    </mc:Choice>
+    <mc:Fallback>
+      <p:transition advClick="1"/>
+    </mc:Fallback>
+  </mc:AlternateContent>
 </p:sld>
 </file>
 
@@ -7881,7 +8550,7 @@
       </p:grpSpPr>
       <p:sp>
         <p:nvSpPr>
-          <p:cNvPr id="158279181" name="TextBox 1"/>
+          <p:cNvPr id="835492771" name="TextBox 1"/>
           <p:cNvSpPr txBox="1"/>
           <p:nvPr/>
         </p:nvSpPr>
@@ -7919,7 +8588,7 @@
       </p:sp>
       <p:sp>
         <p:nvSpPr>
-          <p:cNvPr id="679806233" name="TextBox 2"/>
+          <p:cNvPr id="1599202410" name="TextBox 2"/>
           <p:cNvSpPr txBox="1"/>
           <p:nvPr/>
         </p:nvSpPr>
@@ -7957,7 +8626,7 @@
       </p:sp>
       <p:sp>
         <p:nvSpPr>
-          <p:cNvPr id="1018459780" name="TextBox 3"/>
+          <p:cNvPr id="1699026150" name="TextBox 3"/>
           <p:cNvSpPr txBox="1"/>
           <p:nvPr/>
         </p:nvSpPr>
@@ -7995,7 +8664,7 @@
       </p:sp>
       <p:sp>
         <p:nvSpPr>
-          <p:cNvPr id="1549433485" name="TextBox 4"/>
+          <p:cNvPr id="1373080217" name="TextBox 4"/>
           <p:cNvSpPr txBox="1"/>
           <p:nvPr/>
         </p:nvSpPr>
@@ -8033,7 +8702,7 @@
       </p:sp>
       <p:sp>
         <p:nvSpPr>
-          <p:cNvPr id="1690669087" name="TextBox 5"/>
+          <p:cNvPr id="1038475304" name="TextBox 5"/>
           <p:cNvSpPr txBox="1"/>
           <p:nvPr/>
         </p:nvSpPr>
@@ -8197,6 +8866,87 @@
 </file>
 
 <file path=ppt/slides/slide20.xml><?xml version="1.0" encoding="utf-8"?>
+<p:sld xmlns:a="http://schemas.openxmlformats.org/drawingml/2006/main" xmlns:r="http://schemas.openxmlformats.org/officeDocument/2006/relationships" xmlns:p="http://schemas.openxmlformats.org/presentationml/2006/main" xmlns:m="http://schemas.openxmlformats.org/officeDocument/2006/math" xmlns:w="http://schemas.openxmlformats.org/wordprocessingml/2006/main" xmlns:mc="http://schemas.openxmlformats.org/markup-compatibility/2006" showMasterPhAnim="0" showMasterSp="1" show="1">
+  <p:cSld name="">
+    <p:spTree>
+      <p:nvGrpSpPr>
+        <p:cNvPr id="1" name=""/>
+        <p:cNvGrpSpPr/>
+        <p:nvPr/>
+      </p:nvGrpSpPr>
+      <p:grpSpPr bwMode="auto">
+        <a:xfrm>
+          <a:off x="0" y="0"/>
+          <a:ext cx="0" cy="0"/>
+          <a:chOff x="0" y="0"/>
+          <a:chExt cx="0" cy="0"/>
+        </a:xfrm>
+      </p:grpSpPr>
+      <p:sp>
+        <p:nvSpPr>
+          <p:cNvPr id="145180765" name="Title 1"/>
+          <p:cNvSpPr>
+            <a:spLocks noGrp="1"/>
+          </p:cNvSpPr>
+          <p:nvPr>
+            <p:ph type="title"/>
+          </p:nvPr>
+        </p:nvSpPr>
+        <p:spPr bwMode="auto"/>
+        <p:txBody>
+          <a:bodyPr/>
+          <a:lstStyle/>
+          <a:p>
+            <a:pPr>
+              <a:defRPr/>
+            </a:pPr>
+            <a:r>
+              <a:rPr/>
+              <a:t>Application Screens: Reports</a:t>
+            </a:r>
+            <a:endParaRPr/>
+          </a:p>
+        </p:txBody>
+      </p:sp>
+      <p:pic>
+        <p:nvPicPr>
+          <p:cNvPr id="178692976" name="Picture 2" descr="Reports.png"/>
+          <p:cNvPicPr>
+            <a:picLocks noChangeAspect="1"/>
+          </p:cNvPicPr>
+          <p:nvPr/>
+        </p:nvPicPr>
+        <p:blipFill rotWithShape="1">
+          <a:blip r:embed="rId3"/>
+          <a:stretch/>
+        </p:blipFill>
+        <p:spPr bwMode="auto">
+          <a:xfrm>
+            <a:off x="457200" y="1371600"/>
+            <a:ext cx="8229600" cy="3709749"/>
+          </a:xfrm>
+          <a:prstGeom prst="rect">
+            <a:avLst/>
+          </a:prstGeom>
+        </p:spPr>
+      </p:pic>
+    </p:spTree>
+  </p:cSld>
+  <p:clrMapOvr>
+    <a:masterClrMapping/>
+  </p:clrMapOvr>
+  <mc:AlternateContent xmlns:mc="http://schemas.openxmlformats.org/markup-compatibility/2006">
+    <mc:Choice xmlns:p159="http://schemas.microsoft.com/office/powerpoint/2015/09/main" xmlns:p14="http://schemas.microsoft.com/office/powerpoint/2010/main" Requires="p159">
+      <p:transition p14:dur="500" advClick="1"/>
+    </mc:Choice>
+    <mc:Fallback>
+      <p:transition advClick="1"/>
+    </mc:Fallback>
+  </mc:AlternateContent>
+</p:sld>
+</file>
+
+<file path=ppt/slides/slide21.xml><?xml version="1.0" encoding="utf-8"?>
 <p:sld xmlns:a="http://schemas.openxmlformats.org/drawingml/2006/main" xmlns:p="http://schemas.openxmlformats.org/presentationml/2006/main" xmlns:r="http://schemas.openxmlformats.org/officeDocument/2006/relationships">
   <p:cSld>
     <p:spTree>
@@ -8222,14 +8972,518 @@
           <a:lstStyle/>
           <a:p>
             <a:r>
-              <a:t>Application Screens: Reports</a:t>
+              <a:t>Website: Landing Page</a:t>
             </a:r>
           </a:p>
         </p:txBody>
       </p:sp>
       <p:pic>
         <p:nvPicPr>
-          <p:cNvPr id="3" name="Picture 2" descr="Reports.png"/>
+          <p:cNvPr id="3" name="Picture 2" descr="Landing.png"/>
+          <p:cNvPicPr>
+            <a:picLocks noChangeAspect="1"/>
+          </p:cNvPicPr>
+          <p:nvPr/>
+        </p:nvPicPr>
+        <p:blipFill>
+          <a:blip r:embed="rId2"/>
+          <a:stretch>
+            <a:fillRect/>
+          </a:stretch>
+        </p:blipFill>
+        <p:spPr>
+          <a:xfrm>
+            <a:off x="457200" y="1371600"/>
+            <a:ext cx="8229600" cy="3709749"/>
+          </a:xfrm>
+          <a:prstGeom prst="rect">
+            <a:avLst/>
+          </a:prstGeom>
+        </p:spPr>
+      </p:pic>
+    </p:spTree>
+  </p:cSld>
+  <p:clrMapOvr>
+    <a:masterClrMapping/>
+  </p:clrMapOvr>
+</p:sld>
+</file>
+
+<file path=ppt/slides/slide22.xml><?xml version="1.0" encoding="utf-8"?>
+<p:sld xmlns:a="http://schemas.openxmlformats.org/drawingml/2006/main" xmlns:p="http://schemas.openxmlformats.org/presentationml/2006/main" xmlns:r="http://schemas.openxmlformats.org/officeDocument/2006/relationships">
+  <p:cSld>
+    <p:spTree>
+      <p:nvGrpSpPr>
+        <p:cNvPr id="1" name=""/>
+        <p:cNvGrpSpPr/>
+        <p:nvPr/>
+      </p:nvGrpSpPr>
+      <p:grpSpPr/>
+      <p:sp>
+        <p:nvSpPr>
+          <p:cNvPr id="2" name="Title 1"/>
+          <p:cNvSpPr>
+            <a:spLocks noGrp="1"/>
+          </p:cNvSpPr>
+          <p:nvPr>
+            <p:ph type="title"/>
+          </p:nvPr>
+        </p:nvSpPr>
+        <p:spPr/>
+        <p:txBody>
+          <a:bodyPr/>
+          <a:lstStyle/>
+          <a:p>
+            <a:r>
+              <a:t>Website: About Us</a:t>
+            </a:r>
+          </a:p>
+        </p:txBody>
+      </p:sp>
+      <p:pic>
+        <p:nvPicPr>
+          <p:cNvPr id="3" name="Picture 2" descr="About.png"/>
+          <p:cNvPicPr>
+            <a:picLocks noChangeAspect="1"/>
+          </p:cNvPicPr>
+          <p:nvPr/>
+        </p:nvPicPr>
+        <p:blipFill>
+          <a:blip r:embed="rId2"/>
+          <a:stretch>
+            <a:fillRect/>
+          </a:stretch>
+        </p:blipFill>
+        <p:spPr>
+          <a:xfrm>
+            <a:off x="457200" y="1371600"/>
+            <a:ext cx="8229600" cy="3709749"/>
+          </a:xfrm>
+          <a:prstGeom prst="rect">
+            <a:avLst/>
+          </a:prstGeom>
+        </p:spPr>
+      </p:pic>
+    </p:spTree>
+  </p:cSld>
+  <p:clrMapOvr>
+    <a:masterClrMapping/>
+  </p:clrMapOvr>
+</p:sld>
+</file>
+
+<file path=ppt/slides/slide23.xml><?xml version="1.0" encoding="utf-8"?>
+<p:sld xmlns:a="http://schemas.openxmlformats.org/drawingml/2006/main" xmlns:p="http://schemas.openxmlformats.org/presentationml/2006/main" xmlns:r="http://schemas.openxmlformats.org/officeDocument/2006/relationships">
+  <p:cSld>
+    <p:spTree>
+      <p:nvGrpSpPr>
+        <p:cNvPr id="1" name=""/>
+        <p:cNvGrpSpPr/>
+        <p:nvPr/>
+      </p:nvGrpSpPr>
+      <p:grpSpPr/>
+      <p:sp>
+        <p:nvSpPr>
+          <p:cNvPr id="2" name="Title 1"/>
+          <p:cNvSpPr>
+            <a:spLocks noGrp="1"/>
+          </p:cNvSpPr>
+          <p:nvPr>
+            <p:ph type="title"/>
+          </p:nvPr>
+        </p:nvSpPr>
+        <p:spPr/>
+        <p:txBody>
+          <a:bodyPr/>
+          <a:lstStyle/>
+          <a:p>
+            <a:r>
+              <a:t>Website: Gallery</a:t>
+            </a:r>
+          </a:p>
+        </p:txBody>
+      </p:sp>
+      <p:pic>
+        <p:nvPicPr>
+          <p:cNvPr id="3" name="Picture 2" descr="Gallery.png"/>
+          <p:cNvPicPr>
+            <a:picLocks noChangeAspect="1"/>
+          </p:cNvPicPr>
+          <p:nvPr/>
+        </p:nvPicPr>
+        <p:blipFill>
+          <a:blip r:embed="rId2"/>
+          <a:stretch>
+            <a:fillRect/>
+          </a:stretch>
+        </p:blipFill>
+        <p:spPr>
+          <a:xfrm>
+            <a:off x="457200" y="1371600"/>
+            <a:ext cx="8229600" cy="3709749"/>
+          </a:xfrm>
+          <a:prstGeom prst="rect">
+            <a:avLst/>
+          </a:prstGeom>
+        </p:spPr>
+      </p:pic>
+    </p:spTree>
+  </p:cSld>
+  <p:clrMapOvr>
+    <a:masterClrMapping/>
+  </p:clrMapOvr>
+</p:sld>
+</file>
+
+<file path=ppt/slides/slide24.xml><?xml version="1.0" encoding="utf-8"?>
+<p:sld xmlns:a="http://schemas.openxmlformats.org/drawingml/2006/main" xmlns:p="http://schemas.openxmlformats.org/presentationml/2006/main" xmlns:r="http://schemas.openxmlformats.org/officeDocument/2006/relationships">
+  <p:cSld>
+    <p:spTree>
+      <p:nvGrpSpPr>
+        <p:cNvPr id="1" name=""/>
+        <p:cNvGrpSpPr/>
+        <p:nvPr/>
+      </p:nvGrpSpPr>
+      <p:grpSpPr/>
+      <p:sp>
+        <p:nvSpPr>
+          <p:cNvPr id="2" name="Title 1"/>
+          <p:cNvSpPr>
+            <a:spLocks noGrp="1"/>
+          </p:cNvSpPr>
+          <p:nvPr>
+            <p:ph type="title"/>
+          </p:nvPr>
+        </p:nvSpPr>
+        <p:spPr/>
+        <p:txBody>
+          <a:bodyPr/>
+          <a:lstStyle/>
+          <a:p>
+            <a:r>
+              <a:t>Website: Contact</a:t>
+            </a:r>
+          </a:p>
+        </p:txBody>
+      </p:sp>
+      <p:pic>
+        <p:nvPicPr>
+          <p:cNvPr id="3" name="Picture 2" descr="Contact.png"/>
+          <p:cNvPicPr>
+            <a:picLocks noChangeAspect="1"/>
+          </p:cNvPicPr>
+          <p:nvPr/>
+        </p:nvPicPr>
+        <p:blipFill>
+          <a:blip r:embed="rId2"/>
+          <a:stretch>
+            <a:fillRect/>
+          </a:stretch>
+        </p:blipFill>
+        <p:spPr>
+          <a:xfrm>
+            <a:off x="457200" y="1371600"/>
+            <a:ext cx="8229600" cy="3709749"/>
+          </a:xfrm>
+          <a:prstGeom prst="rect">
+            <a:avLst/>
+          </a:prstGeom>
+        </p:spPr>
+      </p:pic>
+    </p:spTree>
+  </p:cSld>
+  <p:clrMapOvr>
+    <a:masterClrMapping/>
+  </p:clrMapOvr>
+</p:sld>
+</file>
+
+<file path=ppt/slides/slide25.xml><?xml version="1.0" encoding="utf-8"?>
+<p:sld xmlns:a="http://schemas.openxmlformats.org/drawingml/2006/main" xmlns:p="http://schemas.openxmlformats.org/presentationml/2006/main" xmlns:r="http://schemas.openxmlformats.org/officeDocument/2006/relationships">
+  <p:cSld>
+    <p:spTree>
+      <p:nvGrpSpPr>
+        <p:cNvPr id="1" name=""/>
+        <p:cNvGrpSpPr/>
+        <p:nvPr/>
+      </p:nvGrpSpPr>
+      <p:grpSpPr/>
+      <p:sp>
+        <p:nvSpPr>
+          <p:cNvPr id="2" name="Title 1"/>
+          <p:cNvSpPr>
+            <a:spLocks noGrp="1"/>
+          </p:cNvSpPr>
+          <p:nvPr>
+            <p:ph type="title"/>
+          </p:nvPr>
+        </p:nvSpPr>
+        <p:spPr/>
+        <p:txBody>
+          <a:bodyPr/>
+          <a:lstStyle/>
+          <a:p>
+            <a:r>
+              <a:t>Website: Login Portal</a:t>
+            </a:r>
+          </a:p>
+        </p:txBody>
+      </p:sp>
+      <p:pic>
+        <p:nvPicPr>
+          <p:cNvPr id="3" name="Picture 2" descr="Login.png"/>
+          <p:cNvPicPr>
+            <a:picLocks noChangeAspect="1"/>
+          </p:cNvPicPr>
+          <p:nvPr/>
+        </p:nvPicPr>
+        <p:blipFill>
+          <a:blip r:embed="rId2"/>
+          <a:stretch>
+            <a:fillRect/>
+          </a:stretch>
+        </p:blipFill>
+        <p:spPr>
+          <a:xfrm>
+            <a:off x="457200" y="1371600"/>
+            <a:ext cx="8229600" cy="3709749"/>
+          </a:xfrm>
+          <a:prstGeom prst="rect">
+            <a:avLst/>
+          </a:prstGeom>
+        </p:spPr>
+      </p:pic>
+    </p:spTree>
+  </p:cSld>
+  <p:clrMapOvr>
+    <a:masterClrMapping/>
+  </p:clrMapOvr>
+</p:sld>
+</file>
+
+<file path=ppt/slides/slide26.xml><?xml version="1.0" encoding="utf-8"?>
+<p:sld xmlns:a="http://schemas.openxmlformats.org/drawingml/2006/main" xmlns:p="http://schemas.openxmlformats.org/presentationml/2006/main" xmlns:r="http://schemas.openxmlformats.org/officeDocument/2006/relationships">
+  <p:cSld>
+    <p:spTree>
+      <p:nvGrpSpPr>
+        <p:cNvPr id="1" name=""/>
+        <p:cNvGrpSpPr/>
+        <p:nvPr/>
+      </p:nvGrpSpPr>
+      <p:grpSpPr/>
+      <p:sp>
+        <p:nvSpPr>
+          <p:cNvPr id="2" name="Title 1"/>
+          <p:cNvSpPr>
+            <a:spLocks noGrp="1"/>
+          </p:cNvSpPr>
+          <p:nvPr>
+            <p:ph type="title"/>
+          </p:nvPr>
+        </p:nvSpPr>
+        <p:spPr/>
+        <p:txBody>
+          <a:bodyPr/>
+          <a:lstStyle/>
+          <a:p>
+            <a:r>
+              <a:t>User Portal: Dashboard</a:t>
+            </a:r>
+          </a:p>
+        </p:txBody>
+      </p:sp>
+      <p:pic>
+        <p:nvPicPr>
+          <p:cNvPr id="3" name="Picture 2" descr="User_Dashboard.png"/>
+          <p:cNvPicPr>
+            <a:picLocks noChangeAspect="1"/>
+          </p:cNvPicPr>
+          <p:nvPr/>
+        </p:nvPicPr>
+        <p:blipFill>
+          <a:blip r:embed="rId2"/>
+          <a:stretch>
+            <a:fillRect/>
+          </a:stretch>
+        </p:blipFill>
+        <p:spPr>
+          <a:xfrm>
+            <a:off x="457200" y="1371600"/>
+            <a:ext cx="8229600" cy="3709749"/>
+          </a:xfrm>
+          <a:prstGeom prst="rect">
+            <a:avLst/>
+          </a:prstGeom>
+        </p:spPr>
+      </p:pic>
+    </p:spTree>
+  </p:cSld>
+  <p:clrMapOvr>
+    <a:masterClrMapping/>
+  </p:clrMapOvr>
+</p:sld>
+</file>
+
+<file path=ppt/slides/slide27.xml><?xml version="1.0" encoding="utf-8"?>
+<p:sld xmlns:a="http://schemas.openxmlformats.org/drawingml/2006/main" xmlns:p="http://schemas.openxmlformats.org/presentationml/2006/main" xmlns:r="http://schemas.openxmlformats.org/officeDocument/2006/relationships">
+  <p:cSld>
+    <p:spTree>
+      <p:nvGrpSpPr>
+        <p:cNvPr id="1" name=""/>
+        <p:cNvGrpSpPr/>
+        <p:nvPr/>
+      </p:nvGrpSpPr>
+      <p:grpSpPr/>
+      <p:sp>
+        <p:nvSpPr>
+          <p:cNvPr id="2" name="Title 1"/>
+          <p:cNvSpPr>
+            <a:spLocks noGrp="1"/>
+          </p:cNvSpPr>
+          <p:nvPr>
+            <p:ph type="title"/>
+          </p:nvPr>
+        </p:nvSpPr>
+        <p:spPr/>
+        <p:txBody>
+          <a:bodyPr/>
+          <a:lstStyle/>
+          <a:p>
+            <a:r>
+              <a:t>User Portal: Available Blood</a:t>
+            </a:r>
+          </a:p>
+        </p:txBody>
+      </p:sp>
+      <p:pic>
+        <p:nvPicPr>
+          <p:cNvPr id="3" name="Picture 2" descr="User_AvailableBlood.png"/>
+          <p:cNvPicPr>
+            <a:picLocks noChangeAspect="1"/>
+          </p:cNvPicPr>
+          <p:nvPr/>
+        </p:nvPicPr>
+        <p:blipFill>
+          <a:blip r:embed="rId2"/>
+          <a:stretch>
+            <a:fillRect/>
+          </a:stretch>
+        </p:blipFill>
+        <p:spPr>
+          <a:xfrm>
+            <a:off x="457200" y="1371600"/>
+            <a:ext cx="8229600" cy="3709749"/>
+          </a:xfrm>
+          <a:prstGeom prst="rect">
+            <a:avLst/>
+          </a:prstGeom>
+        </p:spPr>
+      </p:pic>
+    </p:spTree>
+  </p:cSld>
+  <p:clrMapOvr>
+    <a:masterClrMapping/>
+  </p:clrMapOvr>
+</p:sld>
+</file>
+
+<file path=ppt/slides/slide28.xml><?xml version="1.0" encoding="utf-8"?>
+<p:sld xmlns:a="http://schemas.openxmlformats.org/drawingml/2006/main" xmlns:p="http://schemas.openxmlformats.org/presentationml/2006/main" xmlns:r="http://schemas.openxmlformats.org/officeDocument/2006/relationships">
+  <p:cSld>
+    <p:spTree>
+      <p:nvGrpSpPr>
+        <p:cNvPr id="1" name=""/>
+        <p:cNvGrpSpPr/>
+        <p:nvPr/>
+      </p:nvGrpSpPr>
+      <p:grpSpPr/>
+      <p:sp>
+        <p:nvSpPr>
+          <p:cNvPr id="2" name="Title 1"/>
+          <p:cNvSpPr>
+            <a:spLocks noGrp="1"/>
+          </p:cNvSpPr>
+          <p:nvPr>
+            <p:ph type="title"/>
+          </p:nvPr>
+        </p:nvSpPr>
+        <p:spPr/>
+        <p:txBody>
+          <a:bodyPr/>
+          <a:lstStyle/>
+          <a:p>
+            <a:r>
+              <a:t>User Portal: Camp Registration</a:t>
+            </a:r>
+          </a:p>
+        </p:txBody>
+      </p:sp>
+      <p:pic>
+        <p:nvPicPr>
+          <p:cNvPr id="3" name="Picture 2" descr="User_CampRegistration.png"/>
+          <p:cNvPicPr>
+            <a:picLocks noChangeAspect="1"/>
+          </p:cNvPicPr>
+          <p:nvPr/>
+        </p:nvPicPr>
+        <p:blipFill>
+          <a:blip r:embed="rId2"/>
+          <a:stretch>
+            <a:fillRect/>
+          </a:stretch>
+        </p:blipFill>
+        <p:spPr>
+          <a:xfrm>
+            <a:off x="457200" y="1371600"/>
+            <a:ext cx="8229600" cy="3709749"/>
+          </a:xfrm>
+          <a:prstGeom prst="rect">
+            <a:avLst/>
+          </a:prstGeom>
+        </p:spPr>
+      </p:pic>
+    </p:spTree>
+  </p:cSld>
+  <p:clrMapOvr>
+    <a:masterClrMapping/>
+  </p:clrMapOvr>
+</p:sld>
+</file>
+
+<file path=ppt/slides/slide29.xml><?xml version="1.0" encoding="utf-8"?>
+<p:sld xmlns:a="http://schemas.openxmlformats.org/drawingml/2006/main" xmlns:p="http://schemas.openxmlformats.org/presentationml/2006/main" xmlns:r="http://schemas.openxmlformats.org/officeDocument/2006/relationships">
+  <p:cSld>
+    <p:spTree>
+      <p:nvGrpSpPr>
+        <p:cNvPr id="1" name=""/>
+        <p:cNvGrpSpPr/>
+        <p:nvPr/>
+      </p:nvGrpSpPr>
+      <p:grpSpPr/>
+      <p:sp>
+        <p:nvSpPr>
+          <p:cNvPr id="2" name="Title 1"/>
+          <p:cNvSpPr>
+            <a:spLocks noGrp="1"/>
+          </p:cNvSpPr>
+          <p:nvPr>
+            <p:ph type="title"/>
+          </p:nvPr>
+        </p:nvSpPr>
+        <p:spPr/>
+        <p:txBody>
+          <a:bodyPr/>
+          <a:lstStyle/>
+          <a:p>
+            <a:r>
+              <a:t>User Portal: Blood Request</a:t>
+            </a:r>
+          </a:p>
+        </p:txBody>
+      </p:sp>
+      <p:pic>
+        <p:nvPicPr>
+          <p:cNvPr id="3" name="Picture 2" descr="User_BloodRequest.png"/>
           <p:cNvPicPr>
             <a:picLocks noChangeAspect="1"/>
           </p:cNvPicPr>
@@ -8285,7 +9539,7 @@
       </p:grpSpPr>
       <p:sp>
         <p:nvSpPr>
-          <p:cNvPr id="1288723505" name="TextBox 1"/>
+          <p:cNvPr id="1716107311" name="TextBox 1"/>
           <p:cNvSpPr txBox="1"/>
           <p:nvPr/>
         </p:nvSpPr>
@@ -8323,7 +9577,7 @@
       </p:sp>
       <p:sp>
         <p:nvSpPr>
-          <p:cNvPr id="1177944485" name="TextBox 2"/>
+          <p:cNvPr id="1482776647" name="TextBox 2"/>
           <p:cNvSpPr txBox="1"/>
           <p:nvPr/>
         </p:nvSpPr>
@@ -8361,7 +9615,7 @@
       </p:sp>
       <p:sp>
         <p:nvSpPr>
-          <p:cNvPr id="870228741" name="TextBox 3"/>
+          <p:cNvPr id="1233032593" name="TextBox 3"/>
           <p:cNvSpPr txBox="1"/>
           <p:nvPr/>
         </p:nvSpPr>
@@ -8399,7 +9653,7 @@
       </p:sp>
       <p:sp>
         <p:nvSpPr>
-          <p:cNvPr id="1733158911" name="TextBox 4"/>
+          <p:cNvPr id="1042459054" name="TextBox 4"/>
           <p:cNvSpPr txBox="1"/>
           <p:nvPr/>
         </p:nvSpPr>
@@ -8437,7 +9691,7 @@
       </p:sp>
       <p:sp>
         <p:nvSpPr>
-          <p:cNvPr id="225297964" name="TextBox 5"/>
+          <p:cNvPr id="96711722" name="TextBox 5"/>
           <p:cNvSpPr txBox="1"/>
           <p:nvPr/>
         </p:nvSpPr>
@@ -8597,6 +9851,69 @@
       <p:transition advClick="1"/>
     </mc:Fallback>
   </mc:AlternateContent>
+</p:sld>
+</file>
+
+<file path=ppt/slides/slide30.xml><?xml version="1.0" encoding="utf-8"?>
+<p:sld xmlns:a="http://schemas.openxmlformats.org/drawingml/2006/main" xmlns:p="http://schemas.openxmlformats.org/presentationml/2006/main" xmlns:r="http://schemas.openxmlformats.org/officeDocument/2006/relationships">
+  <p:cSld>
+    <p:spTree>
+      <p:nvGrpSpPr>
+        <p:cNvPr id="1" name=""/>
+        <p:cNvGrpSpPr/>
+        <p:nvPr/>
+      </p:nvGrpSpPr>
+      <p:grpSpPr/>
+      <p:sp>
+        <p:nvSpPr>
+          <p:cNvPr id="2" name="Title 1"/>
+          <p:cNvSpPr>
+            <a:spLocks noGrp="1"/>
+          </p:cNvSpPr>
+          <p:nvPr>
+            <p:ph type="title"/>
+          </p:nvPr>
+        </p:nvSpPr>
+        <p:spPr/>
+        <p:txBody>
+          <a:bodyPr/>
+          <a:lstStyle/>
+          <a:p>
+            <a:r>
+              <a:t>User Portal: Profile</a:t>
+            </a:r>
+          </a:p>
+        </p:txBody>
+      </p:sp>
+      <p:pic>
+        <p:nvPicPr>
+          <p:cNvPr id="3" name="Picture 2" descr="User_Profile.png"/>
+          <p:cNvPicPr>
+            <a:picLocks noChangeAspect="1"/>
+          </p:cNvPicPr>
+          <p:nvPr/>
+        </p:nvPicPr>
+        <p:blipFill>
+          <a:blip r:embed="rId2"/>
+          <a:stretch>
+            <a:fillRect/>
+          </a:stretch>
+        </p:blipFill>
+        <p:spPr>
+          <a:xfrm>
+            <a:off x="457200" y="1371600"/>
+            <a:ext cx="8229600" cy="3709749"/>
+          </a:xfrm>
+          <a:prstGeom prst="rect">
+            <a:avLst/>
+          </a:prstGeom>
+        </p:spPr>
+      </p:pic>
+    </p:spTree>
+  </p:cSld>
+  <p:clrMapOvr>
+    <a:masterClrMapping/>
+  </p:clrMapOvr>
 </p:sld>
 </file>
 
@@ -8626,7 +9943,7 @@
       </p:grpSpPr>
       <p:sp>
         <p:nvSpPr>
-          <p:cNvPr id="3318797" name="TextBox 1"/>
+          <p:cNvPr id="1706359940" name="TextBox 1"/>
           <p:cNvSpPr txBox="1"/>
           <p:nvPr/>
         </p:nvSpPr>
@@ -8664,7 +9981,7 @@
       </p:sp>
       <p:sp>
         <p:nvSpPr>
-          <p:cNvPr id="344628437" name="TextBox 2"/>
+          <p:cNvPr id="1892682927" name="TextBox 2"/>
           <p:cNvSpPr txBox="1"/>
           <p:nvPr/>
         </p:nvSpPr>
@@ -8702,7 +10019,7 @@
       </p:sp>
       <p:sp>
         <p:nvSpPr>
-          <p:cNvPr id="1472804122" name="TextBox 3"/>
+          <p:cNvPr id="437938906" name="TextBox 3"/>
           <p:cNvSpPr txBox="1"/>
           <p:nvPr/>
         </p:nvSpPr>
@@ -8740,7 +10057,7 @@
       </p:sp>
       <p:sp>
         <p:nvSpPr>
-          <p:cNvPr id="2036874404" name="TextBox 4"/>
+          <p:cNvPr id="871728652" name="TextBox 4"/>
           <p:cNvSpPr txBox="1"/>
           <p:nvPr/>
         </p:nvSpPr>
@@ -8778,7 +10095,7 @@
       </p:sp>
       <p:sp>
         <p:nvSpPr>
-          <p:cNvPr id="1406749565" name="TextBox 5"/>
+          <p:cNvPr id="2053491936" name="TextBox 5"/>
           <p:cNvSpPr txBox="1"/>
           <p:nvPr/>
         </p:nvSpPr>
@@ -8967,7 +10284,7 @@
       </p:grpSpPr>
       <p:sp>
         <p:nvSpPr>
-          <p:cNvPr id="1095068083" name="TextBox 1"/>
+          <p:cNvPr id="1263755219" name="TextBox 1"/>
           <p:cNvSpPr txBox="1"/>
           <p:nvPr/>
         </p:nvSpPr>
@@ -9005,7 +10322,7 @@
       </p:sp>
       <p:sp>
         <p:nvSpPr>
-          <p:cNvPr id="1247528034" name="TextBox 2"/>
+          <p:cNvPr id="1819750120" name="TextBox 2"/>
           <p:cNvSpPr txBox="1"/>
           <p:nvPr/>
         </p:nvSpPr>
@@ -9043,7 +10360,7 @@
       </p:sp>
       <p:sp>
         <p:nvSpPr>
-          <p:cNvPr id="1118694549" name="TextBox 3"/>
+          <p:cNvPr id="431370336" name="TextBox 3"/>
           <p:cNvSpPr txBox="1"/>
           <p:nvPr/>
         </p:nvSpPr>
@@ -9081,7 +10398,7 @@
       </p:sp>
       <p:sp>
         <p:nvSpPr>
-          <p:cNvPr id="1648474633" name="TextBox 4"/>
+          <p:cNvPr id="976629375" name="TextBox 4"/>
           <p:cNvSpPr txBox="1"/>
           <p:nvPr/>
         </p:nvSpPr>
@@ -9119,7 +10436,7 @@
       </p:sp>
       <p:sp>
         <p:nvSpPr>
-          <p:cNvPr id="1670198622" name="Rounded Rectangle 5"/>
+          <p:cNvPr id="916793662" name="Rounded Rectangle 5"/>
           <p:cNvSpPr/>
           <p:nvPr/>
         </p:nvSpPr>
@@ -9170,7 +10487,7 @@
       </p:sp>
       <p:sp>
         <p:nvSpPr>
-          <p:cNvPr id="1808140952" name="TextBox 6"/>
+          <p:cNvPr id="909748532" name="TextBox 6"/>
           <p:cNvSpPr txBox="1"/>
           <p:nvPr/>
         </p:nvSpPr>
@@ -9208,7 +10525,7 @@
       </p:sp>
       <p:sp>
         <p:nvSpPr>
-          <p:cNvPr id="1942162719" name="TextBox 7"/>
+          <p:cNvPr id="227750677" name="TextBox 7"/>
           <p:cNvSpPr txBox="1"/>
           <p:nvPr/>
         </p:nvSpPr>
@@ -9249,7 +10566,7 @@
       </p:sp>
       <p:sp>
         <p:nvSpPr>
-          <p:cNvPr id="1991645523" name="Rounded Rectangle 8"/>
+          <p:cNvPr id="1623992383" name="Rounded Rectangle 8"/>
           <p:cNvSpPr/>
           <p:nvPr/>
         </p:nvSpPr>
@@ -9300,7 +10617,7 @@
       </p:sp>
       <p:sp>
         <p:nvSpPr>
-          <p:cNvPr id="1695419944" name="TextBox 9"/>
+          <p:cNvPr id="1059947346" name="TextBox 9"/>
           <p:cNvSpPr txBox="1"/>
           <p:nvPr/>
         </p:nvSpPr>
@@ -9338,7 +10655,7 @@
       </p:sp>
       <p:sp>
         <p:nvSpPr>
-          <p:cNvPr id="1873276016" name="TextBox 10"/>
+          <p:cNvPr id="639865258" name="TextBox 10"/>
           <p:cNvSpPr txBox="1"/>
           <p:nvPr/>
         </p:nvSpPr>
@@ -9379,7 +10696,7 @@
       </p:sp>
       <p:sp>
         <p:nvSpPr>
-          <p:cNvPr id="1301628288" name="Rounded Rectangle 11"/>
+          <p:cNvPr id="1680111889" name="Rounded Rectangle 11"/>
           <p:cNvSpPr/>
           <p:nvPr/>
         </p:nvSpPr>
@@ -9430,7 +10747,7 @@
       </p:sp>
       <p:sp>
         <p:nvSpPr>
-          <p:cNvPr id="714597158" name="TextBox 12"/>
+          <p:cNvPr id="206436862" name="TextBox 12"/>
           <p:cNvSpPr txBox="1"/>
           <p:nvPr/>
         </p:nvSpPr>
@@ -9468,7 +10785,7 @@
       </p:sp>
       <p:sp>
         <p:nvSpPr>
-          <p:cNvPr id="942678034" name="TextBox 13"/>
+          <p:cNvPr id="102350437" name="TextBox 13"/>
           <p:cNvSpPr txBox="1"/>
           <p:nvPr/>
         </p:nvSpPr>
@@ -9509,7 +10826,7 @@
       </p:sp>
       <p:sp>
         <p:nvSpPr>
-          <p:cNvPr id="1412583388" name="Rounded Rectangle 14"/>
+          <p:cNvPr id="2004193533" name="Rounded Rectangle 14"/>
           <p:cNvSpPr/>
           <p:nvPr/>
         </p:nvSpPr>
@@ -9560,7 +10877,7 @@
       </p:sp>
       <p:sp>
         <p:nvSpPr>
-          <p:cNvPr id="1772892702" name="TextBox 15"/>
+          <p:cNvPr id="1212016057" name="TextBox 15"/>
           <p:cNvSpPr txBox="1"/>
           <p:nvPr/>
         </p:nvSpPr>
@@ -9598,7 +10915,7 @@
       </p:sp>
       <p:sp>
         <p:nvSpPr>
-          <p:cNvPr id="1805888342" name="TextBox 16"/>
+          <p:cNvPr id="1896955851" name="TextBox 16"/>
           <p:cNvSpPr txBox="1"/>
           <p:nvPr/>
         </p:nvSpPr>
@@ -9679,7 +10996,7 @@
       </p:grpSpPr>
       <p:sp>
         <p:nvSpPr>
-          <p:cNvPr id="1367151888" name="TextBox 1"/>
+          <p:cNvPr id="299633218" name="TextBox 1"/>
           <p:cNvSpPr txBox="1"/>
           <p:nvPr/>
         </p:nvSpPr>
@@ -9717,7 +11034,7 @@
       </p:sp>
       <p:sp>
         <p:nvSpPr>
-          <p:cNvPr id="77303805" name="TextBox 2"/>
+          <p:cNvPr id="346964286" name="TextBox 2"/>
           <p:cNvSpPr txBox="1"/>
           <p:nvPr/>
         </p:nvSpPr>
@@ -9755,7 +11072,7 @@
       </p:sp>
       <p:sp>
         <p:nvSpPr>
-          <p:cNvPr id="1318818679" name="TextBox 3"/>
+          <p:cNvPr id="1392337309" name="TextBox 3"/>
           <p:cNvSpPr txBox="1"/>
           <p:nvPr/>
         </p:nvSpPr>
@@ -9793,7 +11110,7 @@
       </p:sp>
       <p:sp>
         <p:nvSpPr>
-          <p:cNvPr id="150130231" name="TextBox 4"/>
+          <p:cNvPr id="1734367156" name="TextBox 4"/>
           <p:cNvSpPr txBox="1"/>
           <p:nvPr/>
         </p:nvSpPr>
@@ -9831,7 +11148,7 @@
       </p:sp>
       <p:sp>
         <p:nvSpPr>
-          <p:cNvPr id="873397771" name="TextBox 5"/>
+          <p:cNvPr id="1804415138" name="TextBox 5"/>
           <p:cNvSpPr txBox="1"/>
           <p:nvPr/>
         </p:nvSpPr>
@@ -10083,7 +11400,7 @@
       </p:grpSpPr>
       <p:sp>
         <p:nvSpPr>
-          <p:cNvPr id="20274216" name="TextBox 1"/>
+          <p:cNvPr id="1043098185" name="TextBox 1"/>
           <p:cNvSpPr txBox="1"/>
           <p:nvPr/>
         </p:nvSpPr>
@@ -10121,7 +11438,7 @@
       </p:sp>
       <p:sp>
         <p:nvSpPr>
-          <p:cNvPr id="1070906477" name="TextBox 2"/>
+          <p:cNvPr id="1308856013" name="TextBox 2"/>
           <p:cNvSpPr txBox="1"/>
           <p:nvPr/>
         </p:nvSpPr>
@@ -10159,7 +11476,7 @@
       </p:sp>
       <p:sp>
         <p:nvSpPr>
-          <p:cNvPr id="409777487" name="TextBox 3"/>
+          <p:cNvPr id="2109169003" name="TextBox 3"/>
           <p:cNvSpPr txBox="1"/>
           <p:nvPr/>
         </p:nvSpPr>
@@ -10197,7 +11514,7 @@
       </p:sp>
       <p:sp>
         <p:nvSpPr>
-          <p:cNvPr id="1891943562" name="TextBox 4"/>
+          <p:cNvPr id="231445359" name="TextBox 4"/>
           <p:cNvSpPr txBox="1"/>
           <p:nvPr/>
         </p:nvSpPr>
@@ -10235,7 +11552,7 @@
       </p:sp>
       <p:sp>
         <p:nvSpPr>
-          <p:cNvPr id="1360107663" name="Oval 5"/>
+          <p:cNvPr id="731870033" name="Oval 5"/>
           <p:cNvSpPr/>
           <p:nvPr/>
         </p:nvSpPr>
@@ -10291,7 +11608,7 @@
       </p:sp>
       <p:sp>
         <p:nvSpPr>
-          <p:cNvPr id="1158473135" name="TextBox 6"/>
+          <p:cNvPr id="422005819" name="TextBox 6"/>
           <p:cNvSpPr txBox="1"/>
           <p:nvPr/>
         </p:nvSpPr>
@@ -10344,7 +11661,7 @@
       </p:sp>
       <p:sp>
         <p:nvSpPr>
-          <p:cNvPr id="679539598" name="Right Arrow 7"/>
+          <p:cNvPr id="1617073867" name="Right Arrow 7"/>
           <p:cNvSpPr/>
           <p:nvPr/>
         </p:nvSpPr>
@@ -10394,7 +11711,7 @@
       </p:sp>
       <p:sp>
         <p:nvSpPr>
-          <p:cNvPr id="465053436" name="Oval 8"/>
+          <p:cNvPr id="31475391" name="Oval 8"/>
           <p:cNvSpPr/>
           <p:nvPr/>
         </p:nvSpPr>
@@ -10450,7 +11767,7 @@
       </p:sp>
       <p:sp>
         <p:nvSpPr>
-          <p:cNvPr id="979514543" name="TextBox 9"/>
+          <p:cNvPr id="720335493" name="TextBox 9"/>
           <p:cNvSpPr txBox="1"/>
           <p:nvPr/>
         </p:nvSpPr>
@@ -10503,7 +11820,7 @@
       </p:sp>
       <p:sp>
         <p:nvSpPr>
-          <p:cNvPr id="898973861" name="Right Arrow 10"/>
+          <p:cNvPr id="1613627105" name="Right Arrow 10"/>
           <p:cNvSpPr/>
           <p:nvPr/>
         </p:nvSpPr>
@@ -10553,7 +11870,7 @@
       </p:sp>
       <p:sp>
         <p:nvSpPr>
-          <p:cNvPr id="213221679" name="Oval 11"/>
+          <p:cNvPr id="1876942285" name="Oval 11"/>
           <p:cNvSpPr/>
           <p:nvPr/>
         </p:nvSpPr>
@@ -10609,7 +11926,7 @@
       </p:sp>
       <p:sp>
         <p:nvSpPr>
-          <p:cNvPr id="2026600899" name="TextBox 12"/>
+          <p:cNvPr id="58352197" name="TextBox 12"/>
           <p:cNvSpPr txBox="1"/>
           <p:nvPr/>
         </p:nvSpPr>
@@ -10662,7 +11979,7 @@
       </p:sp>
       <p:sp>
         <p:nvSpPr>
-          <p:cNvPr id="42959554" name="Right Arrow 13"/>
+          <p:cNvPr id="1597009914" name="Right Arrow 13"/>
           <p:cNvSpPr/>
           <p:nvPr/>
         </p:nvSpPr>
@@ -10712,7 +12029,7 @@
       </p:sp>
       <p:sp>
         <p:nvSpPr>
-          <p:cNvPr id="1831860040" name="Oval 14"/>
+          <p:cNvPr id="337845263" name="Oval 14"/>
           <p:cNvSpPr/>
           <p:nvPr/>
         </p:nvSpPr>
@@ -10768,7 +12085,7 @@
       </p:sp>
       <p:sp>
         <p:nvSpPr>
-          <p:cNvPr id="342611484" name="TextBox 15"/>
+          <p:cNvPr id="1043488281" name="TextBox 15"/>
           <p:cNvSpPr txBox="1"/>
           <p:nvPr/>
         </p:nvSpPr>
@@ -10821,7 +12138,7 @@
       </p:sp>
       <p:sp>
         <p:nvSpPr>
-          <p:cNvPr id="657121080" name="Right Arrow 16"/>
+          <p:cNvPr id="1763937383" name="Right Arrow 16"/>
           <p:cNvSpPr/>
           <p:nvPr/>
         </p:nvSpPr>
@@ -10871,7 +12188,7 @@
       </p:sp>
       <p:sp>
         <p:nvSpPr>
-          <p:cNvPr id="1050182206" name="Oval 17"/>
+          <p:cNvPr id="105188823" name="Oval 17"/>
           <p:cNvSpPr/>
           <p:nvPr/>
         </p:nvSpPr>
@@ -10927,7 +12244,7 @@
       </p:sp>
       <p:sp>
         <p:nvSpPr>
-          <p:cNvPr id="1585453503" name="TextBox 18"/>
+          <p:cNvPr id="1132582274" name="TextBox 18"/>
           <p:cNvSpPr txBox="1"/>
           <p:nvPr/>
         </p:nvSpPr>
@@ -10980,7 +12297,7 @@
       </p:sp>
       <p:sp>
         <p:nvSpPr>
-          <p:cNvPr id="2010442695" name="TextBox 19"/>
+          <p:cNvPr id="570731285" name="TextBox 19"/>
           <p:cNvSpPr txBox="1"/>
           <p:nvPr/>
         </p:nvSpPr>
@@ -11018,7 +12335,7 @@
       </p:sp>
       <p:sp>
         <p:nvSpPr>
-          <p:cNvPr id="1983936062" name="TextBox 20"/>
+          <p:cNvPr id="1115638324" name="TextBox 20"/>
           <p:cNvSpPr txBox="1"/>
           <p:nvPr/>
         </p:nvSpPr>
@@ -11045,6 +12362,7 @@
               <a:defRPr/>
             </a:pPr>
             <a:r>
+              <a:rPr/>
               <a:t>The frontend is built with Vue 3 and communicates with the Node.js backend API, which connects to the MySQL database.</a:t>
             </a:r>
             <a:endParaRPr/>
@@ -11093,7 +12411,7 @@
       </p:grpSpPr>
       <p:sp>
         <p:nvSpPr>
-          <p:cNvPr id="230983885" name="TextBox 1"/>
+          <p:cNvPr id="293771668" name="TextBox 1"/>
           <p:cNvSpPr txBox="1"/>
           <p:nvPr/>
         </p:nvSpPr>
@@ -11131,7 +12449,7 @@
       </p:sp>
       <p:sp>
         <p:nvSpPr>
-          <p:cNvPr id="1351015587" name="TextBox 2"/>
+          <p:cNvPr id="124986452" name="TextBox 2"/>
           <p:cNvSpPr txBox="1"/>
           <p:nvPr/>
         </p:nvSpPr>
@@ -11169,7 +12487,7 @@
       </p:sp>
       <p:sp>
         <p:nvSpPr>
-          <p:cNvPr id="1593673463" name="TextBox 3"/>
+          <p:cNvPr id="542501554" name="TextBox 3"/>
           <p:cNvSpPr txBox="1"/>
           <p:nvPr/>
         </p:nvSpPr>
@@ -11207,7 +12525,7 @@
       </p:sp>
       <p:sp>
         <p:nvSpPr>
-          <p:cNvPr id="687537019" name="TextBox 4"/>
+          <p:cNvPr id="122911309" name="TextBox 4"/>
           <p:cNvSpPr txBox="1"/>
           <p:nvPr/>
         </p:nvSpPr>
@@ -11245,7 +12563,7 @@
       </p:sp>
       <p:sp>
         <p:nvSpPr>
-          <p:cNvPr id="1421669245" name="Rectangle 5"/>
+          <p:cNvPr id="194897987" name="Rectangle 5"/>
           <p:cNvSpPr/>
           <p:nvPr/>
         </p:nvSpPr>
@@ -11292,7 +12610,7 @@
       </p:sp>
       <p:sp>
         <p:nvSpPr>
-          <p:cNvPr id="246106069" name="TextBox 6"/>
+          <p:cNvPr id="1985081424" name="TextBox 6"/>
           <p:cNvSpPr txBox="1"/>
           <p:nvPr/>
         </p:nvSpPr>
@@ -11330,7 +12648,7 @@
       </p:sp>
       <p:sp>
         <p:nvSpPr>
-          <p:cNvPr id="1959387855" name="Rectangle 7"/>
+          <p:cNvPr id="656152501" name="Rectangle 7"/>
           <p:cNvSpPr/>
           <p:nvPr/>
         </p:nvSpPr>
@@ -11377,7 +12695,7 @@
       </p:sp>
       <p:sp>
         <p:nvSpPr>
-          <p:cNvPr id="1201045361" name="TextBox 8"/>
+          <p:cNvPr id="12963045" name="TextBox 8"/>
           <p:cNvSpPr txBox="1"/>
           <p:nvPr/>
         </p:nvSpPr>
@@ -11415,7 +12733,7 @@
       </p:sp>
       <p:sp>
         <p:nvSpPr>
-          <p:cNvPr id="39000758" name="Rectangle 9"/>
+          <p:cNvPr id="1663664152" name="Rectangle 9"/>
           <p:cNvSpPr/>
           <p:nvPr/>
         </p:nvSpPr>
@@ -11462,7 +12780,7 @@
       </p:sp>
       <p:sp>
         <p:nvSpPr>
-          <p:cNvPr id="1891597905" name="TextBox 10"/>
+          <p:cNvPr id="622803773" name="TextBox 10"/>
           <p:cNvSpPr txBox="1"/>
           <p:nvPr/>
         </p:nvSpPr>
@@ -11500,7 +12818,7 @@
       </p:sp>
       <p:sp>
         <p:nvSpPr>
-          <p:cNvPr id="1388657915" name="Rectangle 11"/>
+          <p:cNvPr id="1223390117" name="Rectangle 11"/>
           <p:cNvSpPr/>
           <p:nvPr/>
         </p:nvSpPr>
@@ -11549,7 +12867,7 @@
       </p:sp>
       <p:sp>
         <p:nvSpPr>
-          <p:cNvPr id="330203603" name="TextBox 12"/>
+          <p:cNvPr id="269474377" name="TextBox 12"/>
           <p:cNvSpPr txBox="1"/>
           <p:nvPr/>
         </p:nvSpPr>
@@ -11590,7 +12908,7 @@
       </p:sp>
       <p:sp>
         <p:nvSpPr>
-          <p:cNvPr id="1638561092" name="Rectangle 13"/>
+          <p:cNvPr id="2137192366" name="Rectangle 13"/>
           <p:cNvSpPr/>
           <p:nvPr/>
         </p:nvSpPr>
@@ -11639,7 +12957,7 @@
       </p:sp>
       <p:sp>
         <p:nvSpPr>
-          <p:cNvPr id="1979500138" name="TextBox 14"/>
+          <p:cNvPr id="2098129224" name="TextBox 14"/>
           <p:cNvSpPr txBox="1"/>
           <p:nvPr/>
         </p:nvSpPr>
@@ -11680,7 +12998,7 @@
       </p:sp>
       <p:sp>
         <p:nvSpPr>
-          <p:cNvPr id="7433371" name="Rectangle 15"/>
+          <p:cNvPr id="384782813" name="Rectangle 15"/>
           <p:cNvSpPr/>
           <p:nvPr/>
         </p:nvSpPr>
@@ -11729,7 +13047,7 @@
       </p:sp>
       <p:sp>
         <p:nvSpPr>
-          <p:cNvPr id="1696263871" name="TextBox 16"/>
+          <p:cNvPr id="1359244299" name="TextBox 16"/>
           <p:cNvSpPr txBox="1"/>
           <p:nvPr/>
         </p:nvSpPr>
@@ -11770,7 +13088,7 @@
       </p:sp>
       <p:sp>
         <p:nvSpPr>
-          <p:cNvPr id="469096265" name="Rectangle 17"/>
+          <p:cNvPr id="906729194" name="Rectangle 17"/>
           <p:cNvSpPr/>
           <p:nvPr/>
         </p:nvSpPr>
@@ -11819,7 +13137,7 @@
       </p:sp>
       <p:sp>
         <p:nvSpPr>
-          <p:cNvPr id="1424737243" name="TextBox 18"/>
+          <p:cNvPr id="1926448407" name="TextBox 18"/>
           <p:cNvSpPr txBox="1"/>
           <p:nvPr/>
         </p:nvSpPr>
@@ -11860,7 +13178,7 @@
       </p:sp>
       <p:sp>
         <p:nvSpPr>
-          <p:cNvPr id="821977690" name="Rectangle 19"/>
+          <p:cNvPr id="509036650" name="Rectangle 19"/>
           <p:cNvSpPr/>
           <p:nvPr/>
         </p:nvSpPr>
@@ -11909,7 +13227,7 @@
       </p:sp>
       <p:sp>
         <p:nvSpPr>
-          <p:cNvPr id="1406674566" name="TextBox 20"/>
+          <p:cNvPr id="1149557939" name="TextBox 20"/>
           <p:cNvSpPr txBox="1"/>
           <p:nvPr/>
         </p:nvSpPr>
@@ -11950,7 +13268,7 @@
       </p:sp>
       <p:sp>
         <p:nvSpPr>
-          <p:cNvPr id="1285241972" name="Rectangle 21"/>
+          <p:cNvPr id="927951609" name="Rectangle 21"/>
           <p:cNvSpPr/>
           <p:nvPr/>
         </p:nvSpPr>
@@ -11999,7 +13317,7 @@
       </p:sp>
       <p:sp>
         <p:nvSpPr>
-          <p:cNvPr id="663640159" name="TextBox 22"/>
+          <p:cNvPr id="1371883440" name="TextBox 22"/>
           <p:cNvSpPr txBox="1"/>
           <p:nvPr/>
         </p:nvSpPr>
@@ -12040,7 +13358,7 @@
       </p:sp>
       <p:sp>
         <p:nvSpPr>
-          <p:cNvPr id="1252377568" name="Rectangle 23"/>
+          <p:cNvPr id="1163812513" name="Rectangle 23"/>
           <p:cNvSpPr/>
           <p:nvPr/>
         </p:nvSpPr>
@@ -12089,7 +13407,7 @@
       </p:sp>
       <p:sp>
         <p:nvSpPr>
-          <p:cNvPr id="1873740736" name="TextBox 24"/>
+          <p:cNvPr id="544877043" name="TextBox 24"/>
           <p:cNvSpPr txBox="1"/>
           <p:nvPr/>
         </p:nvSpPr>
@@ -12130,7 +13448,7 @@
       </p:sp>
       <p:sp>
         <p:nvSpPr>
-          <p:cNvPr id="2273393" name="Rectangle 25"/>
+          <p:cNvPr id="988142884" name="Rectangle 25"/>
           <p:cNvSpPr/>
           <p:nvPr/>
         </p:nvSpPr>
@@ -12179,7 +13497,7 @@
       </p:sp>
       <p:sp>
         <p:nvSpPr>
-          <p:cNvPr id="1893157356" name="TextBox 26"/>
+          <p:cNvPr id="1291113683" name="TextBox 26"/>
           <p:cNvSpPr txBox="1"/>
           <p:nvPr/>
         </p:nvSpPr>
@@ -12220,7 +13538,7 @@
       </p:sp>
       <p:sp>
         <p:nvSpPr>
-          <p:cNvPr id="1960809381" name="Rectangle 27"/>
+          <p:cNvPr id="860741548" name="Rectangle 27"/>
           <p:cNvSpPr/>
           <p:nvPr/>
         </p:nvSpPr>
@@ -12269,7 +13587,7 @@
       </p:sp>
       <p:sp>
         <p:nvSpPr>
-          <p:cNvPr id="1267372952" name="TextBox 28"/>
+          <p:cNvPr id="1327706793" name="TextBox 28"/>
           <p:cNvSpPr txBox="1"/>
           <p:nvPr/>
         </p:nvSpPr>
@@ -12310,7 +13628,7 @@
       </p:sp>
       <p:sp>
         <p:nvSpPr>
-          <p:cNvPr id="861356189" name="Rectangle 29"/>
+          <p:cNvPr id="580270771" name="Rectangle 29"/>
           <p:cNvSpPr/>
           <p:nvPr/>
         </p:nvSpPr>
@@ -12359,7 +13677,7 @@
       </p:sp>
       <p:sp>
         <p:nvSpPr>
-          <p:cNvPr id="1234980557" name="TextBox 30"/>
+          <p:cNvPr id="378839919" name="TextBox 30"/>
           <p:cNvSpPr txBox="1"/>
           <p:nvPr/>
         </p:nvSpPr>
@@ -12418,7 +13736,7 @@
       </p:sp>
       <p:sp>
         <p:nvSpPr>
-          <p:cNvPr id="2036858021" name="Rectangle 31"/>
+          <p:cNvPr id="1873285355" name="Rectangle 31"/>
           <p:cNvSpPr/>
           <p:nvPr/>
         </p:nvSpPr>
@@ -12467,7 +13785,7 @@
       </p:sp>
       <p:sp>
         <p:nvSpPr>
-          <p:cNvPr id="530214411" name="TextBox 32"/>
+          <p:cNvPr id="480329120" name="TextBox 32"/>
           <p:cNvSpPr txBox="1"/>
           <p:nvPr/>
         </p:nvSpPr>
@@ -12508,7 +13826,7 @@
       </p:sp>
       <p:sp>
         <p:nvSpPr>
-          <p:cNvPr id="2042524643" name="Rectangle 33"/>
+          <p:cNvPr id="1262370641" name="Rectangle 33"/>
           <p:cNvSpPr/>
           <p:nvPr/>
         </p:nvSpPr>
@@ -12557,7 +13875,7 @@
       </p:sp>
       <p:sp>
         <p:nvSpPr>
-          <p:cNvPr id="1737560089" name="TextBox 34"/>
+          <p:cNvPr id="209507756" name="TextBox 34"/>
           <p:cNvSpPr txBox="1"/>
           <p:nvPr/>
         </p:nvSpPr>
@@ -12598,7 +13916,7 @@
       </p:sp>
       <p:sp>
         <p:nvSpPr>
-          <p:cNvPr id="1098120062" name="Rectangle 35"/>
+          <p:cNvPr id="1973659854" name="Rectangle 35"/>
           <p:cNvSpPr/>
           <p:nvPr/>
         </p:nvSpPr>
@@ -12647,7 +13965,7 @@
       </p:sp>
       <p:sp>
         <p:nvSpPr>
-          <p:cNvPr id="1786765375" name="TextBox 36"/>
+          <p:cNvPr id="1960229611" name="TextBox 36"/>
           <p:cNvSpPr txBox="1"/>
           <p:nvPr/>
         </p:nvSpPr>
@@ -12688,7 +14006,7 @@
       </p:sp>
       <p:sp>
         <p:nvSpPr>
-          <p:cNvPr id="594000968" name="Rectangle 37"/>
+          <p:cNvPr id="1633915885" name="Rectangle 37"/>
           <p:cNvSpPr/>
           <p:nvPr/>
         </p:nvSpPr>
@@ -12737,7 +14055,7 @@
       </p:sp>
       <p:sp>
         <p:nvSpPr>
-          <p:cNvPr id="1723953347" name="TextBox 38"/>
+          <p:cNvPr id="711347389" name="TextBox 38"/>
           <p:cNvSpPr txBox="1"/>
           <p:nvPr/>
         </p:nvSpPr>
@@ -12778,7 +14096,7 @@
       </p:sp>
       <p:sp>
         <p:nvSpPr>
-          <p:cNvPr id="369821602" name="Rectangle 39"/>
+          <p:cNvPr id="943212536" name="Rectangle 39"/>
           <p:cNvSpPr/>
           <p:nvPr/>
         </p:nvSpPr>
@@ -12827,7 +14145,7 @@
       </p:sp>
       <p:sp>
         <p:nvSpPr>
-          <p:cNvPr id="1972007653" name="TextBox 40"/>
+          <p:cNvPr id="1712562622" name="TextBox 40"/>
           <p:cNvSpPr txBox="1"/>
           <p:nvPr/>
         </p:nvSpPr>
@@ -12868,7 +14186,7 @@
       </p:sp>
       <p:sp>
         <p:nvSpPr>
-          <p:cNvPr id="1302611456" name="Rectangle 41"/>
+          <p:cNvPr id="1248343127" name="Rectangle 41"/>
           <p:cNvSpPr/>
           <p:nvPr/>
         </p:nvSpPr>
@@ -12917,7 +14235,7 @@
       </p:sp>
       <p:sp>
         <p:nvSpPr>
-          <p:cNvPr id="381946692" name="TextBox 42"/>
+          <p:cNvPr id="642698938" name="TextBox 42"/>
           <p:cNvSpPr txBox="1"/>
           <p:nvPr/>
         </p:nvSpPr>
@@ -12976,7 +14294,7 @@
       </p:sp>
       <p:sp>
         <p:nvSpPr>
-          <p:cNvPr id="1595656082" name="Rectangle 43"/>
+          <p:cNvPr id="1471383362" name="Rectangle 43"/>
           <p:cNvSpPr/>
           <p:nvPr/>
         </p:nvSpPr>
@@ -13025,7 +14343,7 @@
       </p:sp>
       <p:sp>
         <p:nvSpPr>
-          <p:cNvPr id="777711240" name="TextBox 44"/>
+          <p:cNvPr id="946123703" name="TextBox 44"/>
           <p:cNvSpPr txBox="1"/>
           <p:nvPr/>
         </p:nvSpPr>
@@ -13066,7 +14384,7 @@
       </p:sp>
       <p:sp>
         <p:nvSpPr>
-          <p:cNvPr id="339497964" name="Rectangle 45"/>
+          <p:cNvPr id="1596853695" name="Rectangle 45"/>
           <p:cNvSpPr/>
           <p:nvPr/>
         </p:nvSpPr>
@@ -13115,7 +14433,7 @@
       </p:sp>
       <p:sp>
         <p:nvSpPr>
-          <p:cNvPr id="1698540148" name="TextBox 46"/>
+          <p:cNvPr id="427720355" name="TextBox 46"/>
           <p:cNvSpPr txBox="1"/>
           <p:nvPr/>
         </p:nvSpPr>
@@ -13196,7 +14514,7 @@
       </p:grpSpPr>
       <p:sp>
         <p:nvSpPr>
-          <p:cNvPr id="631271090" name="TextBox 1"/>
+          <p:cNvPr id="1261481230" name="TextBox 1"/>
           <p:cNvSpPr txBox="1"/>
           <p:nvPr/>
         </p:nvSpPr>
@@ -13234,7 +14552,7 @@
       </p:sp>
       <p:sp>
         <p:nvSpPr>
-          <p:cNvPr id="1983280638" name="TextBox 2"/>
+          <p:cNvPr id="1054775670" name="TextBox 2"/>
           <p:cNvSpPr txBox="1"/>
           <p:nvPr/>
         </p:nvSpPr>
@@ -13272,7 +14590,7 @@
       </p:sp>
       <p:sp>
         <p:nvSpPr>
-          <p:cNvPr id="226271159" name="TextBox 3"/>
+          <p:cNvPr id="340641525" name="TextBox 3"/>
           <p:cNvSpPr txBox="1"/>
           <p:nvPr/>
         </p:nvSpPr>
@@ -13310,7 +14628,7 @@
       </p:sp>
       <p:sp>
         <p:nvSpPr>
-          <p:cNvPr id="95437982" name="TextBox 4"/>
+          <p:cNvPr id="1191807462" name="TextBox 4"/>
           <p:cNvSpPr txBox="1"/>
           <p:nvPr/>
         </p:nvSpPr>
@@ -13348,7 +14666,7 @@
       </p:sp>
       <p:sp>
         <p:nvSpPr>
-          <p:cNvPr id="281839516" name="TextBox 5"/>
+          <p:cNvPr id="1250052463" name="TextBox 5"/>
           <p:cNvSpPr txBox="1"/>
           <p:nvPr/>
         </p:nvSpPr>

</xml_diff>